<commit_message>
Falta coregir graficos cmg y verificar extracción de vertimientos 2026
</commit_message>
<xml_diff>
--- a/data/processed/reports/reporte_generacion.pptx
+++ b/data/processed/reports/reporte_generacion.pptx
@@ -133,12 +133,12 @@
   <pc:docChgLst>
     <pc:chgData name="Pablo Inzunza" userId="be16ff5b34c21876" providerId="LiveId" clId="{CC6937A5-FA4E-485C-A7D4-0E92CAEDBC02}"/>
     <pc:docChg chg="undo custSel modSld">
-      <pc:chgData name="Pablo Inzunza" userId="be16ff5b34c21876" providerId="LiveId" clId="{CC6937A5-FA4E-485C-A7D4-0E92CAEDBC02}" dt="2026-03-22T02:46:25.307" v="1518" actId="20577"/>
+      <pc:chgData name="Pablo Inzunza" userId="be16ff5b34c21876" providerId="LiveId" clId="{CC6937A5-FA4E-485C-A7D4-0E92CAEDBC02}" dt="2026-03-27T23:16:01.630" v="1522" actId="20577"/>
       <pc:docMkLst>
         <pc:docMk/>
       </pc:docMkLst>
       <pc:sldChg chg="addSp delSp modSp mod">
-        <pc:chgData name="Pablo Inzunza" userId="be16ff5b34c21876" providerId="LiveId" clId="{CC6937A5-FA4E-485C-A7D4-0E92CAEDBC02}" dt="2026-03-22T01:57:01.275" v="1510"/>
+        <pc:chgData name="Pablo Inzunza" userId="be16ff5b34c21876" providerId="LiveId" clId="{CC6937A5-FA4E-485C-A7D4-0E92CAEDBC02}" dt="2026-03-27T23:16:01.630" v="1522" actId="20577"/>
         <pc:sldMkLst>
           <pc:docMk/>
           <pc:sldMk cId="1567814596" sldId="256"/>
@@ -216,7 +216,7 @@
           </ac:spMkLst>
         </pc:spChg>
         <pc:spChg chg="add mod">
-          <ac:chgData name="Pablo Inzunza" userId="be16ff5b34c21876" providerId="LiveId" clId="{CC6937A5-FA4E-485C-A7D4-0E92CAEDBC02}" dt="2026-03-21T16:51:16.553" v="1454" actId="1076"/>
+          <ac:chgData name="Pablo Inzunza" userId="be16ff5b34c21876" providerId="LiveId" clId="{CC6937A5-FA4E-485C-A7D4-0E92CAEDBC02}" dt="2026-03-27T23:15:59.165" v="1520" actId="20577"/>
           <ac:spMkLst>
             <pc:docMk/>
             <pc:sldMk cId="1567814596" sldId="256"/>
@@ -224,7 +224,7 @@
           </ac:spMkLst>
         </pc:spChg>
         <pc:spChg chg="add mod">
-          <ac:chgData name="Pablo Inzunza" userId="be16ff5b34c21876" providerId="LiveId" clId="{CC6937A5-FA4E-485C-A7D4-0E92CAEDBC02}" dt="2026-03-21T16:51:19.829" v="1455" actId="1076"/>
+          <ac:chgData name="Pablo Inzunza" userId="be16ff5b34c21876" providerId="LiveId" clId="{CC6937A5-FA4E-485C-A7D4-0E92CAEDBC02}" dt="2026-03-27T23:16:01.630" v="1522" actId="20577"/>
           <ac:spMkLst>
             <pc:docMk/>
             <pc:sldMk cId="1567814596" sldId="256"/>
@@ -239,44 +239,12 @@
             <ac:spMk id="14" creationId="{BC640CFB-D442-9CAF-05C2-333332C40FD7}"/>
           </ac:spMkLst>
         </pc:spChg>
-        <pc:spChg chg="add del mod">
-          <ac:chgData name="Pablo Inzunza" userId="be16ff5b34c21876" providerId="LiveId" clId="{CC6937A5-FA4E-485C-A7D4-0E92CAEDBC02}" dt="2026-03-21T16:38:20.728" v="1417" actId="478"/>
-          <ac:spMkLst>
-            <pc:docMk/>
-            <pc:sldMk cId="1567814596" sldId="256"/>
-            <ac:spMk id="15" creationId="{113C2EAD-B857-ADBF-753C-4CF369BB8BEE}"/>
-          </ac:spMkLst>
-        </pc:spChg>
         <pc:spChg chg="add mod">
           <ac:chgData name="Pablo Inzunza" userId="be16ff5b34c21876" providerId="LiveId" clId="{CC6937A5-FA4E-485C-A7D4-0E92CAEDBC02}" dt="2026-03-22T01:57:01.275" v="1510"/>
           <ac:spMkLst>
             <pc:docMk/>
             <pc:sldMk cId="1567814596" sldId="256"/>
             <ac:spMk id="15" creationId="{B4B0F660-3CC5-7C43-FBBB-E5E307ED2E66}"/>
-          </ac:spMkLst>
-        </pc:spChg>
-        <pc:spChg chg="add del mod">
-          <ac:chgData name="Pablo Inzunza" userId="be16ff5b34c21876" providerId="LiveId" clId="{CC6937A5-FA4E-485C-A7D4-0E92CAEDBC02}" dt="2026-03-21T16:38:20.728" v="1417" actId="478"/>
-          <ac:spMkLst>
-            <pc:docMk/>
-            <pc:sldMk cId="1567814596" sldId="256"/>
-            <ac:spMk id="16" creationId="{FC279485-E6B2-75B4-5A6D-7B330DA8EC68}"/>
-          </ac:spMkLst>
-        </pc:spChg>
-        <pc:spChg chg="add del mod">
-          <ac:chgData name="Pablo Inzunza" userId="be16ff5b34c21876" providerId="LiveId" clId="{CC6937A5-FA4E-485C-A7D4-0E92CAEDBC02}" dt="2026-03-21T16:38:20.728" v="1417" actId="478"/>
-          <ac:spMkLst>
-            <pc:docMk/>
-            <pc:sldMk cId="1567814596" sldId="256"/>
-            <ac:spMk id="17" creationId="{A5098A2E-E0DD-C51B-3171-F7D4BDB66FBA}"/>
-          </ac:spMkLst>
-        </pc:spChg>
-        <pc:spChg chg="add mod">
-          <ac:chgData name="Pablo Inzunza" userId="be16ff5b34c21876" providerId="LiveId" clId="{CC6937A5-FA4E-485C-A7D4-0E92CAEDBC02}" dt="2026-03-21T15:49:00.616" v="1203"/>
-          <ac:spMkLst>
-            <pc:docMk/>
-            <pc:sldMk cId="1567814596" sldId="256"/>
-            <ac:spMk id="18" creationId="{20BA1ECC-2922-A935-2D00-AF0F3548C179}"/>
           </ac:spMkLst>
         </pc:spChg>
         <pc:spChg chg="add mod">
@@ -287,76 +255,12 @@
             <ac:spMk id="18" creationId="{2375222D-2F78-AD62-BF92-27130F75C1C1}"/>
           </ac:spMkLst>
         </pc:spChg>
-        <pc:spChg chg="add del mod">
-          <ac:chgData name="Pablo Inzunza" userId="be16ff5b34c21876" providerId="LiveId" clId="{CC6937A5-FA4E-485C-A7D4-0E92CAEDBC02}" dt="2026-03-21T16:38:20.728" v="1417" actId="478"/>
-          <ac:spMkLst>
-            <pc:docMk/>
-            <pc:sldMk cId="1567814596" sldId="256"/>
-            <ac:spMk id="19" creationId="{781DABF3-EE42-FCAC-3BC4-B31846C56CDE}"/>
-          </ac:spMkLst>
-        </pc:spChg>
-        <pc:spChg chg="add del mod">
-          <ac:chgData name="Pablo Inzunza" userId="be16ff5b34c21876" providerId="LiveId" clId="{CC6937A5-FA4E-485C-A7D4-0E92CAEDBC02}" dt="2026-03-21T16:38:20.728" v="1417" actId="478"/>
-          <ac:spMkLst>
-            <pc:docMk/>
-            <pc:sldMk cId="1567814596" sldId="256"/>
-            <ac:spMk id="20" creationId="{A81CAB28-1D72-B48B-6595-23A6B2E712AE}"/>
-          </ac:spMkLst>
-        </pc:spChg>
-        <pc:spChg chg="add del mod">
-          <ac:chgData name="Pablo Inzunza" userId="be16ff5b34c21876" providerId="LiveId" clId="{CC6937A5-FA4E-485C-A7D4-0E92CAEDBC02}" dt="2026-03-21T16:38:20.728" v="1417" actId="478"/>
-          <ac:spMkLst>
-            <pc:docMk/>
-            <pc:sldMk cId="1567814596" sldId="256"/>
-            <ac:spMk id="21" creationId="{B296EC70-EE89-AB8A-BBA4-BB1470366BA6}"/>
-          </ac:spMkLst>
-        </pc:spChg>
-        <pc:spChg chg="add del mod">
-          <ac:chgData name="Pablo Inzunza" userId="be16ff5b34c21876" providerId="LiveId" clId="{CC6937A5-FA4E-485C-A7D4-0E92CAEDBC02}" dt="2026-03-21T16:38:20.728" v="1417" actId="478"/>
-          <ac:spMkLst>
-            <pc:docMk/>
-            <pc:sldMk cId="1567814596" sldId="256"/>
-            <ac:spMk id="22" creationId="{4A9A5098-92E2-35DC-B79F-D8C12E491AD2}"/>
-          </ac:spMkLst>
-        </pc:spChg>
         <pc:spChg chg="mod">
           <ac:chgData name="Pablo Inzunza" userId="be16ff5b34c21876" providerId="LiveId" clId="{CC6937A5-FA4E-485C-A7D4-0E92CAEDBC02}" dt="2026-03-21T14:46:45.849" v="838" actId="207"/>
           <ac:spMkLst>
             <pc:docMk/>
             <pc:sldMk cId="1567814596" sldId="256"/>
             <ac:spMk id="23" creationId="{470618BE-80E3-6578-FCC8-D12F7C467F04}"/>
-          </ac:spMkLst>
-        </pc:spChg>
-        <pc:spChg chg="add del mod">
-          <ac:chgData name="Pablo Inzunza" userId="be16ff5b34c21876" providerId="LiveId" clId="{CC6937A5-FA4E-485C-A7D4-0E92CAEDBC02}" dt="2026-03-21T16:38:20.728" v="1417" actId="478"/>
-          <ac:spMkLst>
-            <pc:docMk/>
-            <pc:sldMk cId="1567814596" sldId="256"/>
-            <ac:spMk id="24" creationId="{A100D73A-7C35-29B0-790A-39A09D8CE5DE}"/>
-          </ac:spMkLst>
-        </pc:spChg>
-        <pc:spChg chg="mod">
-          <ac:chgData name="Pablo Inzunza" userId="be16ff5b34c21876" providerId="LiveId" clId="{CC6937A5-FA4E-485C-A7D4-0E92CAEDBC02}" dt="2026-03-21T13:55:53.310" v="356" actId="34136"/>
-          <ac:spMkLst>
-            <pc:docMk/>
-            <pc:sldMk cId="1567814596" sldId="256"/>
-            <ac:spMk id="25" creationId="{4EA10392-2533-5083-3D42-B270BFF2008E}"/>
-          </ac:spMkLst>
-        </pc:spChg>
-        <pc:spChg chg="add del mod">
-          <ac:chgData name="Pablo Inzunza" userId="be16ff5b34c21876" providerId="LiveId" clId="{CC6937A5-FA4E-485C-A7D4-0E92CAEDBC02}" dt="2026-03-21T16:38:20.728" v="1417" actId="478"/>
-          <ac:spMkLst>
-            <pc:docMk/>
-            <pc:sldMk cId="1567814596" sldId="256"/>
-            <ac:spMk id="25" creationId="{8B615CDB-9907-5FDA-643E-F9723531D462}"/>
-          </ac:spMkLst>
-        </pc:spChg>
-        <pc:spChg chg="add del mod">
-          <ac:chgData name="Pablo Inzunza" userId="be16ff5b34c21876" providerId="LiveId" clId="{CC6937A5-FA4E-485C-A7D4-0E92CAEDBC02}" dt="2026-03-21T16:38:20.728" v="1417" actId="478"/>
-          <ac:spMkLst>
-            <pc:docMk/>
-            <pc:sldMk cId="1567814596" sldId="256"/>
-            <ac:spMk id="27" creationId="{70B7A1B5-EDE9-FD1C-682C-DDDDE0DC3A61}"/>
           </ac:spMkLst>
         </pc:spChg>
         <pc:spChg chg="add mod">
@@ -383,36 +287,12 @@
             <ac:spMk id="30" creationId="{532544CC-1C67-18AE-B59E-F19E5A86667F}"/>
           </ac:spMkLst>
         </pc:spChg>
-        <pc:spChg chg="mod">
-          <ac:chgData name="Pablo Inzunza" userId="be16ff5b34c21876" providerId="LiveId" clId="{CC6937A5-FA4E-485C-A7D4-0E92CAEDBC02}" dt="2026-03-21T13:55:53.310" v="356" actId="34136"/>
-          <ac:spMkLst>
-            <pc:docMk/>
-            <pc:sldMk cId="1567814596" sldId="256"/>
-            <ac:spMk id="30" creationId="{A38A1DF2-4121-CCA3-05E7-F4DE4ED06DAC}"/>
-          </ac:spMkLst>
-        </pc:spChg>
         <pc:spChg chg="add mod">
           <ac:chgData name="Pablo Inzunza" userId="be16ff5b34c21876" providerId="LiveId" clId="{CC6937A5-FA4E-485C-A7D4-0E92CAEDBC02}" dt="2026-03-21T16:38:33.637" v="1418"/>
           <ac:spMkLst>
             <pc:docMk/>
             <pc:sldMk cId="1567814596" sldId="256"/>
             <ac:spMk id="31" creationId="{2CAE3186-5C44-57B4-43B9-63A2689E8B9D}"/>
-          </ac:spMkLst>
-        </pc:spChg>
-        <pc:spChg chg="mod">
-          <ac:chgData name="Pablo Inzunza" userId="be16ff5b34c21876" providerId="LiveId" clId="{CC6937A5-FA4E-485C-A7D4-0E92CAEDBC02}" dt="2026-03-21T13:55:53.310" v="356" actId="34136"/>
-          <ac:spMkLst>
-            <pc:docMk/>
-            <pc:sldMk cId="1567814596" sldId="256"/>
-            <ac:spMk id="31" creationId="{BDDFB370-EBF1-6CD6-5123-23F2F1D3937F}"/>
-          </ac:spMkLst>
-        </pc:spChg>
-        <pc:spChg chg="mod">
-          <ac:chgData name="Pablo Inzunza" userId="be16ff5b34c21876" providerId="LiveId" clId="{CC6937A5-FA4E-485C-A7D4-0E92CAEDBC02}" dt="2026-03-21T13:55:53.310" v="356" actId="34136"/>
-          <ac:spMkLst>
-            <pc:docMk/>
-            <pc:sldMk cId="1567814596" sldId="256"/>
-            <ac:spMk id="32" creationId="{4D4417FE-7CFB-581B-329C-DC62FDB4DC8A}"/>
           </ac:spMkLst>
         </pc:spChg>
         <pc:spChg chg="add mod">
@@ -423,68 +303,12 @@
             <ac:spMk id="32" creationId="{D683ACCB-ABC1-00AB-7206-B504E2159DB3}"/>
           </ac:spMkLst>
         </pc:spChg>
-        <pc:spChg chg="add del mod">
-          <ac:chgData name="Pablo Inzunza" userId="be16ff5b34c21876" providerId="LiveId" clId="{CC6937A5-FA4E-485C-A7D4-0E92CAEDBC02}" dt="2026-03-22T01:56:58.159" v="1509" actId="478"/>
-          <ac:spMkLst>
-            <pc:docMk/>
-            <pc:sldMk cId="1567814596" sldId="256"/>
-            <ac:spMk id="33" creationId="{E3080204-BBF6-84B4-8294-33217DD052E2}"/>
-          </ac:spMkLst>
-        </pc:spChg>
-        <pc:grpChg chg="del mod">
-          <ac:chgData name="Pablo Inzunza" userId="be16ff5b34c21876" providerId="LiveId" clId="{CC6937A5-FA4E-485C-A7D4-0E92CAEDBC02}" dt="2026-03-21T13:55:55.485" v="357" actId="478"/>
-          <ac:grpSpMkLst>
-            <pc:docMk/>
-            <pc:sldMk cId="1567814596" sldId="256"/>
-            <ac:grpSpMk id="19" creationId="{81922438-34E2-11A8-043B-60AE569049FD}"/>
-          </ac:grpSpMkLst>
-        </pc:grpChg>
         <pc:picChg chg="add mod">
           <ac:chgData name="Pablo Inzunza" userId="be16ff5b34c21876" providerId="LiveId" clId="{CC6937A5-FA4E-485C-A7D4-0E92CAEDBC02}" dt="2026-03-21T13:55:56.770" v="358"/>
           <ac:picMkLst>
             <pc:docMk/>
             <pc:sldMk cId="1567814596" sldId="256"/>
             <ac:picMk id="6" creationId="{1FAE8E5D-1E43-A4B1-9A2A-6D098BE746BC}"/>
-          </ac:picMkLst>
-        </pc:picChg>
-        <pc:picChg chg="add del mod">
-          <ac:chgData name="Pablo Inzunza" userId="be16ff5b34c21876" providerId="LiveId" clId="{CC6937A5-FA4E-485C-A7D4-0E92CAEDBC02}" dt="2026-03-21T16:31:16.293" v="1388" actId="478"/>
-          <ac:picMkLst>
-            <pc:docMk/>
-            <pc:sldMk cId="1567814596" sldId="256"/>
-            <ac:picMk id="11" creationId="{8D34B8F5-0BA1-802C-5F84-F39075FD973C}"/>
-          </ac:picMkLst>
-        </pc:picChg>
-        <pc:picChg chg="add del mod">
-          <ac:chgData name="Pablo Inzunza" userId="be16ff5b34c21876" providerId="LiveId" clId="{CC6937A5-FA4E-485C-A7D4-0E92CAEDBC02}" dt="2026-03-21T16:31:16.878" v="1389" actId="478"/>
-          <ac:picMkLst>
-            <pc:docMk/>
-            <pc:sldMk cId="1567814596" sldId="256"/>
-            <ac:picMk id="12" creationId="{8C1EC1A2-8BEE-4DBB-4178-848AA8E8B0DC}"/>
-          </ac:picMkLst>
-        </pc:picChg>
-        <pc:picChg chg="add del mod">
-          <ac:chgData name="Pablo Inzunza" userId="be16ff5b34c21876" providerId="LiveId" clId="{CC6937A5-FA4E-485C-A7D4-0E92CAEDBC02}" dt="2026-03-21T16:31:17.582" v="1390" actId="478"/>
-          <ac:picMkLst>
-            <pc:docMk/>
-            <pc:sldMk cId="1567814596" sldId="256"/>
-            <ac:picMk id="13" creationId="{47C1491B-3E0E-25F6-4AD2-DE2A140E7620}"/>
-          </ac:picMkLst>
-        </pc:picChg>
-        <pc:picChg chg="mod">
-          <ac:chgData name="Pablo Inzunza" userId="be16ff5b34c21876" providerId="LiveId" clId="{CC6937A5-FA4E-485C-A7D4-0E92CAEDBC02}" dt="2026-03-21T13:55:53.310" v="356" actId="34136"/>
-          <ac:picMkLst>
-            <pc:docMk/>
-            <pc:sldMk cId="1567814596" sldId="256"/>
-            <ac:picMk id="21" creationId="{C66DD272-C03B-441D-A760-5B89541BBE36}"/>
-          </ac:picMkLst>
-        </pc:picChg>
-        <pc:picChg chg="mod">
-          <ac:chgData name="Pablo Inzunza" userId="be16ff5b34c21876" providerId="LiveId" clId="{CC6937A5-FA4E-485C-A7D4-0E92CAEDBC02}" dt="2026-03-21T13:55:53.310" v="356" actId="34136"/>
-          <ac:picMkLst>
-            <pc:docMk/>
-            <pc:sldMk cId="1567814596" sldId="256"/>
-            <ac:picMk id="27" creationId="{5A6D1A26-5E2D-9017-4712-063F40C474D4}"/>
           </ac:picMkLst>
         </pc:picChg>
         <pc:cxnChg chg="mod">
@@ -582,22 +406,6 @@
             <ac:spMk id="12" creationId="{8B5B6252-38CB-E86F-7778-CCCB047C9F0E}"/>
           </ac:spMkLst>
         </pc:spChg>
-        <pc:spChg chg="add del mod">
-          <ac:chgData name="Pablo Inzunza" userId="be16ff5b34c21876" providerId="LiveId" clId="{CC6937A5-FA4E-485C-A7D4-0E92CAEDBC02}" dt="2026-03-22T01:56:24.078" v="1505" actId="478"/>
-          <ac:spMkLst>
-            <pc:docMk/>
-            <pc:sldMk cId="1318690124" sldId="257"/>
-            <ac:spMk id="13" creationId="{7A9E681C-D0F8-E8B4-43B3-4985CE13B5F2}"/>
-          </ac:spMkLst>
-        </pc:spChg>
-        <pc:spChg chg="add del mod">
-          <ac:chgData name="Pablo Inzunza" userId="be16ff5b34c21876" providerId="LiveId" clId="{CC6937A5-FA4E-485C-A7D4-0E92CAEDBC02}" dt="2026-03-21T16:36:16.653" v="1405" actId="478"/>
-          <ac:spMkLst>
-            <pc:docMk/>
-            <pc:sldMk cId="1318690124" sldId="257"/>
-            <ac:spMk id="14" creationId="{38D99553-A305-9C67-A5B6-39AA8AEF663F}"/>
-          </ac:spMkLst>
-        </pc:spChg>
         <pc:spChg chg="add mod">
           <ac:chgData name="Pablo Inzunza" userId="be16ff5b34c21876" providerId="LiveId" clId="{CC6937A5-FA4E-485C-A7D4-0E92CAEDBC02}" dt="2026-03-22T01:44:34.786" v="1504" actId="962"/>
           <ac:spMkLst>
@@ -612,14 +420,6 @@
             <pc:docMk/>
             <pc:sldMk cId="1318690124" sldId="257"/>
             <ac:spMk id="15" creationId="{32AD3C9E-DDDF-4D9D-B63D-2A470824C62E}"/>
-          </ac:spMkLst>
-        </pc:spChg>
-        <pc:spChg chg="add del mod">
-          <ac:chgData name="Pablo Inzunza" userId="be16ff5b34c21876" providerId="LiveId" clId="{CC6937A5-FA4E-485C-A7D4-0E92CAEDBC02}" dt="2026-03-21T16:36:11.069" v="1402" actId="478"/>
-          <ac:spMkLst>
-            <pc:docMk/>
-            <pc:sldMk cId="1318690124" sldId="257"/>
-            <ac:spMk id="15" creationId="{AA70AF45-8965-7CAA-3FFD-A59B27FEBEB0}"/>
           </ac:spMkLst>
         </pc:spChg>
         <pc:spChg chg="mod">
@@ -654,36 +454,12 @@
             <ac:spMk id="19" creationId="{6959F0E8-D105-D742-C106-E9C86706510C}"/>
           </ac:spMkLst>
         </pc:spChg>
-        <pc:spChg chg="add del mod">
-          <ac:chgData name="Pablo Inzunza" userId="be16ff5b34c21876" providerId="LiveId" clId="{CC6937A5-FA4E-485C-A7D4-0E92CAEDBC02}" dt="2026-03-21T16:36:17.607" v="1406" actId="478"/>
-          <ac:spMkLst>
-            <pc:docMk/>
-            <pc:sldMk cId="1318690124" sldId="257"/>
-            <ac:spMk id="19" creationId="{D82E4024-2D91-B596-049E-3E01E350EEBF}"/>
-          </ac:spMkLst>
-        </pc:spChg>
         <pc:spChg chg="add mod">
           <ac:chgData name="Pablo Inzunza" userId="be16ff5b34c21876" providerId="LiveId" clId="{CC6937A5-FA4E-485C-A7D4-0E92CAEDBC02}" dt="2026-03-22T01:56:41.340" v="1508"/>
           <ac:spMkLst>
             <pc:docMk/>
             <pc:sldMk cId="1318690124" sldId="257"/>
             <ac:spMk id="20" creationId="{B1B55D47-CF28-DB6B-E628-594A6C1F6DB8}"/>
-          </ac:spMkLst>
-        </pc:spChg>
-        <pc:spChg chg="add del mod">
-          <ac:chgData name="Pablo Inzunza" userId="be16ff5b34c21876" providerId="LiveId" clId="{CC6937A5-FA4E-485C-A7D4-0E92CAEDBC02}" dt="2026-03-21T16:36:24.316" v="1411" actId="478"/>
-          <ac:spMkLst>
-            <pc:docMk/>
-            <pc:sldMk cId="1318690124" sldId="257"/>
-            <ac:spMk id="20" creationId="{D3D23205-E1C0-A772-4E9E-71D85BB59216}"/>
-          </ac:spMkLst>
-        </pc:spChg>
-        <pc:spChg chg="add del mod">
-          <ac:chgData name="Pablo Inzunza" userId="be16ff5b34c21876" providerId="LiveId" clId="{CC6937A5-FA4E-485C-A7D4-0E92CAEDBC02}" dt="2026-03-21T16:36:22.781" v="1410" actId="478"/>
-          <ac:spMkLst>
-            <pc:docMk/>
-            <pc:sldMk cId="1318690124" sldId="257"/>
-            <ac:spMk id="21" creationId="{CE678B47-E779-0794-2C39-4C5C5DA205DC}"/>
           </ac:spMkLst>
         </pc:spChg>
         <pc:spChg chg="mod">
@@ -694,28 +470,12 @@
             <ac:spMk id="22" creationId="{C3DE91E4-B638-A3E9-761B-B57DC14FC8AD}"/>
           </ac:spMkLst>
         </pc:spChg>
-        <pc:spChg chg="add del mod">
-          <ac:chgData name="Pablo Inzunza" userId="be16ff5b34c21876" providerId="LiveId" clId="{CC6937A5-FA4E-485C-A7D4-0E92CAEDBC02}" dt="2026-03-21T16:36:26.116" v="1412" actId="478"/>
-          <ac:spMkLst>
-            <pc:docMk/>
-            <pc:sldMk cId="1318690124" sldId="257"/>
-            <ac:spMk id="23" creationId="{B4DF88B3-4C8F-7B26-A3EF-6238A3000DE5}"/>
-          </ac:spMkLst>
-        </pc:spChg>
         <pc:spChg chg="mod">
           <ac:chgData name="Pablo Inzunza" userId="be16ff5b34c21876" providerId="LiveId" clId="{CC6937A5-FA4E-485C-A7D4-0E92CAEDBC02}" dt="2026-03-21T14:41:34.155" v="834" actId="207"/>
           <ac:spMkLst>
             <pc:docMk/>
             <pc:sldMk cId="1318690124" sldId="257"/>
             <ac:spMk id="24" creationId="{1DDD93A7-DCBA-B230-6C8C-0C1A8BD925B2}"/>
-          </ac:spMkLst>
-        </pc:spChg>
-        <pc:spChg chg="add del mod">
-          <ac:chgData name="Pablo Inzunza" userId="be16ff5b34c21876" providerId="LiveId" clId="{CC6937A5-FA4E-485C-A7D4-0E92CAEDBC02}" dt="2026-03-21T16:36:30.058" v="1414" actId="478"/>
-          <ac:spMkLst>
-            <pc:docMk/>
-            <pc:sldMk cId="1318690124" sldId="257"/>
-            <ac:spMk id="25" creationId="{6D9609C8-082F-B66E-CFEB-09324E0521E9}"/>
           </ac:spMkLst>
         </pc:spChg>
         <pc:spChg chg="mod">
@@ -726,44 +486,12 @@
             <ac:spMk id="26" creationId="{635183C3-63D2-1F5C-1885-FB3EB55E9821}"/>
           </ac:spMkLst>
         </pc:spChg>
-        <pc:spChg chg="add del mod">
-          <ac:chgData name="Pablo Inzunza" userId="be16ff5b34c21876" providerId="LiveId" clId="{CC6937A5-FA4E-485C-A7D4-0E92CAEDBC02}" dt="2026-03-21T16:36:31.549" v="1415" actId="478"/>
-          <ac:spMkLst>
-            <pc:docMk/>
-            <pc:sldMk cId="1318690124" sldId="257"/>
-            <ac:spMk id="28" creationId="{9CCA45EC-A42E-4F24-5130-A517797F3710}"/>
-          </ac:spMkLst>
-        </pc:spChg>
-        <pc:spChg chg="add del mod">
-          <ac:chgData name="Pablo Inzunza" userId="be16ff5b34c21876" providerId="LiveId" clId="{CC6937A5-FA4E-485C-A7D4-0E92CAEDBC02}" dt="2026-03-22T01:56:26.518" v="1506" actId="478"/>
-          <ac:spMkLst>
-            <pc:docMk/>
-            <pc:sldMk cId="1318690124" sldId="257"/>
-            <ac:spMk id="29" creationId="{43B29D3E-5659-4384-1BB7-0B4D00B64EC9}"/>
-          </ac:spMkLst>
-        </pc:spChg>
         <pc:spChg chg="add mod">
           <ac:chgData name="Pablo Inzunza" userId="be16ff5b34c21876" providerId="LiveId" clId="{CC6937A5-FA4E-485C-A7D4-0E92CAEDBC02}" dt="2026-03-21T16:36:50.106" v="1416"/>
           <ac:spMkLst>
             <pc:docMk/>
             <pc:sldMk cId="1318690124" sldId="257"/>
             <ac:spMk id="30" creationId="{20CA8919-6D7E-E05E-F338-1DFDCF723379}"/>
-          </ac:spMkLst>
-        </pc:spChg>
-        <pc:spChg chg="add del mod">
-          <ac:chgData name="Pablo Inzunza" userId="be16ff5b34c21876" providerId="LiveId" clId="{CC6937A5-FA4E-485C-A7D4-0E92CAEDBC02}" dt="2026-03-21T16:36:27.733" v="1413" actId="478"/>
-          <ac:spMkLst>
-            <pc:docMk/>
-            <pc:sldMk cId="1318690124" sldId="257"/>
-            <ac:spMk id="31" creationId="{85D1EDEC-ACA5-B3D4-28C4-3EE04B79291C}"/>
-          </ac:spMkLst>
-        </pc:spChg>
-        <pc:spChg chg="mod">
-          <ac:chgData name="Pablo Inzunza" userId="be16ff5b34c21876" providerId="LiveId" clId="{CC6937A5-FA4E-485C-A7D4-0E92CAEDBC02}" dt="2026-03-21T13:55:37.804" v="351" actId="34136"/>
-          <ac:spMkLst>
-            <pc:docMk/>
-            <pc:sldMk cId="1318690124" sldId="257"/>
-            <ac:spMk id="31" creationId="{B3EDA84E-48AF-BB5F-C13E-A83AB448BAA8}"/>
           </ac:spMkLst>
         </pc:spChg>
         <pc:spChg chg="add mod">
@@ -782,108 +510,12 @@
             <ac:spMk id="33" creationId="{6D3157EE-83C7-6C4A-D1A1-F3C3E2D99E0D}"/>
           </ac:spMkLst>
         </pc:spChg>
-        <pc:spChg chg="mod">
-          <ac:chgData name="Pablo Inzunza" userId="be16ff5b34c21876" providerId="LiveId" clId="{CC6937A5-FA4E-485C-A7D4-0E92CAEDBC02}" dt="2026-03-21T13:55:37.804" v="351" actId="34136"/>
-          <ac:spMkLst>
-            <pc:docMk/>
-            <pc:sldMk cId="1318690124" sldId="257"/>
-            <ac:spMk id="34" creationId="{B367FA57-8CF5-1C10-2208-7BCEA99B0481}"/>
-          </ac:spMkLst>
-        </pc:spChg>
-        <pc:spChg chg="add del mod">
-          <ac:chgData name="Pablo Inzunza" userId="be16ff5b34c21876" providerId="LiveId" clId="{CC6937A5-FA4E-485C-A7D4-0E92CAEDBC02}" dt="2026-03-22T01:56:28.646" v="1507" actId="478"/>
-          <ac:spMkLst>
-            <pc:docMk/>
-            <pc:sldMk cId="1318690124" sldId="257"/>
-            <ac:spMk id="34" creationId="{F9C5307C-DC4A-5263-57EA-E008049C85DA}"/>
-          </ac:spMkLst>
-        </pc:spChg>
-        <pc:spChg chg="mod">
-          <ac:chgData name="Pablo Inzunza" userId="be16ff5b34c21876" providerId="LiveId" clId="{CC6937A5-FA4E-485C-A7D4-0E92CAEDBC02}" dt="2026-03-21T13:55:41.125" v="352" actId="6549"/>
-          <ac:spMkLst>
-            <pc:docMk/>
-            <pc:sldMk cId="1318690124" sldId="257"/>
-            <ac:spMk id="35" creationId="{72F6A78F-813D-56B6-1ECD-BBA5581EEAAE}"/>
-          </ac:spMkLst>
-        </pc:spChg>
-        <pc:spChg chg="mod">
-          <ac:chgData name="Pablo Inzunza" userId="be16ff5b34c21876" providerId="LiveId" clId="{CC6937A5-FA4E-485C-A7D4-0E92CAEDBC02}" dt="2026-03-21T13:55:37.804" v="351" actId="34136"/>
-          <ac:spMkLst>
-            <pc:docMk/>
-            <pc:sldMk cId="1318690124" sldId="257"/>
-            <ac:spMk id="36" creationId="{89381C84-F153-3CF7-46C9-E4B16A0B4DAB}"/>
-          </ac:spMkLst>
-        </pc:spChg>
-        <pc:grpChg chg="del mod">
-          <ac:chgData name="Pablo Inzunza" userId="be16ff5b34c21876" providerId="LiveId" clId="{CC6937A5-FA4E-485C-A7D4-0E92CAEDBC02}" dt="2026-03-21T13:55:45.428" v="354" actId="478"/>
-          <ac:grpSpMkLst>
-            <pc:docMk/>
-            <pc:sldMk cId="1318690124" sldId="257"/>
-            <ac:grpSpMk id="28" creationId="{0D21D9B5-8A82-AA14-5E21-0805250645F7}"/>
-          </ac:grpSpMkLst>
-        </pc:grpChg>
         <pc:picChg chg="add mod">
           <ac:chgData name="Pablo Inzunza" userId="be16ff5b34c21876" providerId="LiveId" clId="{CC6937A5-FA4E-485C-A7D4-0E92CAEDBC02}" dt="2026-03-21T13:55:47.147" v="355"/>
           <ac:picMkLst>
             <pc:docMk/>
             <pc:sldMk cId="1318690124" sldId="257"/>
             <ac:picMk id="6" creationId="{E408347F-49F3-A2DF-DB85-792C5FC4E46D}"/>
-          </ac:picMkLst>
-        </pc:picChg>
-        <pc:picChg chg="add del mod">
-          <ac:chgData name="Pablo Inzunza" userId="be16ff5b34c21876" providerId="LiveId" clId="{CC6937A5-FA4E-485C-A7D4-0E92CAEDBC02}" dt="2026-03-21T16:31:13.654" v="1385" actId="478"/>
-          <ac:picMkLst>
-            <pc:docMk/>
-            <pc:sldMk cId="1318690124" sldId="257"/>
-            <ac:picMk id="11" creationId="{0179022E-0D0F-8C5B-7DF1-44C50E375BBA}"/>
-          </ac:picMkLst>
-        </pc:picChg>
-        <pc:picChg chg="add del mod">
-          <ac:chgData name="Pablo Inzunza" userId="be16ff5b34c21876" providerId="LiveId" clId="{CC6937A5-FA4E-485C-A7D4-0E92CAEDBC02}" dt="2026-03-21T16:31:14.213" v="1386" actId="478"/>
-          <ac:picMkLst>
-            <pc:docMk/>
-            <pc:sldMk cId="1318690124" sldId="257"/>
-            <ac:picMk id="12" creationId="{743BE4D1-BF71-6B65-6C8F-CDFA4A75A119}"/>
-          </ac:picMkLst>
-        </pc:picChg>
-        <pc:picChg chg="add del mod">
-          <ac:chgData name="Pablo Inzunza" userId="be16ff5b34c21876" providerId="LiveId" clId="{CC6937A5-FA4E-485C-A7D4-0E92CAEDBC02}" dt="2026-03-21T16:31:14.830" v="1387" actId="478"/>
-          <ac:picMkLst>
-            <pc:docMk/>
-            <pc:sldMk cId="1318690124" sldId="257"/>
-            <ac:picMk id="13" creationId="{2B7F81B7-A14C-DE33-12E5-BE5889C22DC4}"/>
-          </ac:picMkLst>
-        </pc:picChg>
-        <pc:picChg chg="mod">
-          <ac:chgData name="Pablo Inzunza" userId="be16ff5b34c21876" providerId="LiveId" clId="{CC6937A5-FA4E-485C-A7D4-0E92CAEDBC02}" dt="2026-03-21T13:55:37.804" v="351" actId="34136"/>
-          <ac:picMkLst>
-            <pc:docMk/>
-            <pc:sldMk cId="1318690124" sldId="257"/>
-            <ac:picMk id="29" creationId="{7AB97237-D587-2A7A-D147-042B3877270D}"/>
-          </ac:picMkLst>
-        </pc:picChg>
-        <pc:picChg chg="add mod">
-          <ac:chgData name="Pablo Inzunza" userId="be16ff5b34c21876" providerId="LiveId" clId="{CC6937A5-FA4E-485C-A7D4-0E92CAEDBC02}" dt="2026-03-21T15:44:45.347" v="1063"/>
-          <ac:picMkLst>
-            <pc:docMk/>
-            <pc:sldMk cId="1318690124" sldId="257"/>
-            <ac:picMk id="29" creationId="{B876E20D-0B8F-E49A-3F6C-A5817A606CBD}"/>
-          </ac:picMkLst>
-        </pc:picChg>
-        <pc:picChg chg="add mod">
-          <ac:chgData name="Pablo Inzunza" userId="be16ff5b34c21876" providerId="LiveId" clId="{CC6937A5-FA4E-485C-A7D4-0E92CAEDBC02}" dt="2026-03-21T15:44:48.347" v="1064"/>
-          <ac:picMkLst>
-            <pc:docMk/>
-            <pc:sldMk cId="1318690124" sldId="257"/>
-            <ac:picMk id="30" creationId="{1F363C94-84CD-58CF-45AB-EF504045AE74}"/>
-          </ac:picMkLst>
-        </pc:picChg>
-        <pc:picChg chg="del mod">
-          <ac:chgData name="Pablo Inzunza" userId="be16ff5b34c21876" providerId="LiveId" clId="{CC6937A5-FA4E-485C-A7D4-0E92CAEDBC02}" dt="2026-03-21T13:55:44.804" v="353" actId="478"/>
-          <ac:picMkLst>
-            <pc:docMk/>
-            <pc:sldMk cId="1318690124" sldId="257"/>
-            <ac:picMk id="33" creationId="{1BDD774F-6A13-76E7-BCD0-34D1968DF825}"/>
           </ac:picMkLst>
         </pc:picChg>
         <pc:cxnChg chg="mod">
@@ -933,14 +565,6 @@
             <ac:spMk id="6" creationId="{000A578B-A20E-7908-578D-E18B24957BF2}"/>
           </ac:spMkLst>
         </pc:spChg>
-        <pc:spChg chg="add del mod">
-          <ac:chgData name="Pablo Inzunza" userId="be16ff5b34c21876" providerId="LiveId" clId="{CC6937A5-FA4E-485C-A7D4-0E92CAEDBC02}" dt="2026-03-21T14:02:30.862" v="495" actId="478"/>
-          <ac:spMkLst>
-            <pc:docMk/>
-            <pc:sldMk cId="315006707" sldId="259"/>
-            <ac:spMk id="6" creationId="{84F53689-A4EC-76C3-4E1D-B4696037308C}"/>
-          </ac:spMkLst>
-        </pc:spChg>
         <pc:spChg chg="add mod ord">
           <ac:chgData name="Pablo Inzunza" userId="be16ff5b34c21876" providerId="LiveId" clId="{CC6937A5-FA4E-485C-A7D4-0E92CAEDBC02}" dt="2026-03-21T14:49:40.286" v="848" actId="14100"/>
           <ac:spMkLst>
@@ -973,36 +597,12 @@
             <ac:spMk id="10" creationId="{70D2677A-770C-318F-6217-1E531D1F3702}"/>
           </ac:spMkLst>
         </pc:spChg>
-        <pc:spChg chg="del mod">
-          <ac:chgData name="Pablo Inzunza" userId="be16ff5b34c21876" providerId="LiveId" clId="{CC6937A5-FA4E-485C-A7D4-0E92CAEDBC02}" dt="2026-03-21T14:01:52.102" v="484" actId="478"/>
-          <ac:spMkLst>
-            <pc:docMk/>
-            <pc:sldMk cId="315006707" sldId="259"/>
-            <ac:spMk id="10" creationId="{B94141C6-AF0A-5EEE-E06A-C7ADAD832418}"/>
-          </ac:spMkLst>
-        </pc:spChg>
-        <pc:spChg chg="del mod">
-          <ac:chgData name="Pablo Inzunza" userId="be16ff5b34c21876" providerId="LiveId" clId="{CC6937A5-FA4E-485C-A7D4-0E92CAEDBC02}" dt="2026-03-21T14:01:51.461" v="483" actId="478"/>
-          <ac:spMkLst>
-            <pc:docMk/>
-            <pc:sldMk cId="315006707" sldId="259"/>
-            <ac:spMk id="11" creationId="{3DB16137-132D-DC43-4F47-12244820A1BC}"/>
-          </ac:spMkLst>
-        </pc:spChg>
         <pc:spChg chg="add mod">
           <ac:chgData name="Pablo Inzunza" userId="be16ff5b34c21876" providerId="LiveId" clId="{CC6937A5-FA4E-485C-A7D4-0E92CAEDBC02}" dt="2026-03-22T01:26:28.694" v="1457"/>
           <ac:spMkLst>
             <pc:docMk/>
             <pc:sldMk cId="315006707" sldId="259"/>
             <ac:spMk id="11" creationId="{A2DC9657-1264-A813-03DC-3FDF24159EB4}"/>
-          </ac:spMkLst>
-        </pc:spChg>
-        <pc:spChg chg="add del mod">
-          <ac:chgData name="Pablo Inzunza" userId="be16ff5b34c21876" providerId="LiveId" clId="{CC6937A5-FA4E-485C-A7D4-0E92CAEDBC02}" dt="2026-03-21T16:35:21.051" v="1397" actId="478"/>
-          <ac:spMkLst>
-            <pc:docMk/>
-            <pc:sldMk cId="315006707" sldId="259"/>
-            <ac:spMk id="11" creationId="{D2DB5A9E-F939-2361-8CFE-BD3A92346D66}"/>
           </ac:spMkLst>
         </pc:spChg>
         <pc:spChg chg="mod">
@@ -1019,30 +619,6 @@
             <pc:docMk/>
             <pc:sldMk cId="315006707" sldId="259"/>
             <ac:spMk id="13" creationId="{2BED03D5-C8B5-D234-BF38-36DAB19265BF}"/>
-          </ac:spMkLst>
-        </pc:spChg>
-        <pc:spChg chg="add del mod">
-          <ac:chgData name="Pablo Inzunza" userId="be16ff5b34c21876" providerId="LiveId" clId="{CC6937A5-FA4E-485C-A7D4-0E92CAEDBC02}" dt="2026-03-21T16:35:23.380" v="1399" actId="478"/>
-          <ac:spMkLst>
-            <pc:docMk/>
-            <pc:sldMk cId="315006707" sldId="259"/>
-            <ac:spMk id="14" creationId="{705DE155-DA8B-EDDC-696D-5D89C4FCD2B4}"/>
-          </ac:spMkLst>
-        </pc:spChg>
-        <pc:spChg chg="add del mod">
-          <ac:chgData name="Pablo Inzunza" userId="be16ff5b34c21876" providerId="LiveId" clId="{CC6937A5-FA4E-485C-A7D4-0E92CAEDBC02}" dt="2026-03-21T14:02:30.862" v="495" actId="478"/>
-          <ac:spMkLst>
-            <pc:docMk/>
-            <pc:sldMk cId="315006707" sldId="259"/>
-            <ac:spMk id="14" creationId="{EF23481B-AFFE-1DF7-1DD4-7A4C02C62173}"/>
-          </ac:spMkLst>
-        </pc:spChg>
-        <pc:spChg chg="del mod">
-          <ac:chgData name="Pablo Inzunza" userId="be16ff5b34c21876" providerId="LiveId" clId="{CC6937A5-FA4E-485C-A7D4-0E92CAEDBC02}" dt="2026-03-21T13:47:43.594" v="297" actId="478"/>
-          <ac:spMkLst>
-            <pc:docMk/>
-            <pc:sldMk cId="315006707" sldId="259"/>
-            <ac:spMk id="14" creationId="{FF7C722F-9063-9D48-1EC4-C1E295146C78}"/>
           </ac:spMkLst>
         </pc:spChg>
         <pc:spChg chg="mod">
@@ -1069,14 +645,6 @@
             <ac:spMk id="17" creationId="{05F5D0CB-D0AA-EE82-E3D5-42C67015D445}"/>
           </ac:spMkLst>
         </pc:spChg>
-        <pc:spChg chg="del mod">
-          <ac:chgData name="Pablo Inzunza" userId="be16ff5b34c21876" providerId="LiveId" clId="{CC6937A5-FA4E-485C-A7D4-0E92CAEDBC02}" dt="2026-03-21T13:47:43.066" v="296" actId="478"/>
-          <ac:spMkLst>
-            <pc:docMk/>
-            <pc:sldMk cId="315006707" sldId="259"/>
-            <ac:spMk id="17" creationId="{D6E6AF4A-1DB9-6D06-B5C9-2FDA3F2E6904}"/>
-          </ac:spMkLst>
-        </pc:spChg>
         <pc:spChg chg="add mod ord">
           <ac:chgData name="Pablo Inzunza" userId="be16ff5b34c21876" providerId="LiveId" clId="{CC6937A5-FA4E-485C-A7D4-0E92CAEDBC02}" dt="2026-03-21T15:59:21.184" v="1372" actId="962"/>
           <ac:spMkLst>
@@ -1099,22 +667,6 @@
             <pc:docMk/>
             <pc:sldMk cId="315006707" sldId="259"/>
             <ac:spMk id="20" creationId="{D074A6F0-4B53-95B0-A880-60470F1EA1FC}"/>
-          </ac:spMkLst>
-        </pc:spChg>
-        <pc:spChg chg="del">
-          <ac:chgData name="Pablo Inzunza" userId="be16ff5b34c21876" providerId="LiveId" clId="{CC6937A5-FA4E-485C-A7D4-0E92CAEDBC02}" dt="2026-03-21T13:34:29.881" v="177" actId="478"/>
-          <ac:spMkLst>
-            <pc:docMk/>
-            <pc:sldMk cId="315006707" sldId="259"/>
-            <ac:spMk id="21" creationId="{4C24B7D0-229A-B8F3-DAA3-3D947D0AC2C7}"/>
-          </ac:spMkLst>
-        </pc:spChg>
-        <pc:spChg chg="add del mod">
-          <ac:chgData name="Pablo Inzunza" userId="be16ff5b34c21876" providerId="LiveId" clId="{CC6937A5-FA4E-485C-A7D4-0E92CAEDBC02}" dt="2026-03-21T16:35:24.924" v="1400" actId="478"/>
-          <ac:spMkLst>
-            <pc:docMk/>
-            <pc:sldMk cId="315006707" sldId="259"/>
-            <ac:spMk id="21" creationId="{692F6F5D-AC26-DD5B-54A2-FBC96E770072}"/>
           </ac:spMkLst>
         </pc:spChg>
         <pc:spChg chg="mod">
@@ -1197,44 +749,12 @@
             <ac:spMk id="32" creationId="{EACB6DFB-AB94-626B-15C5-C99FA0818214}"/>
           </ac:spMkLst>
         </pc:spChg>
-        <pc:spChg chg="add del mod">
-          <ac:chgData name="Pablo Inzunza" userId="be16ff5b34c21876" providerId="LiveId" clId="{CC6937A5-FA4E-485C-A7D4-0E92CAEDBC02}" dt="2026-03-22T01:26:24.453" v="1456" actId="478"/>
-          <ac:spMkLst>
-            <pc:docMk/>
-            <pc:sldMk cId="315006707" sldId="259"/>
-            <ac:spMk id="33" creationId="{D58C5EEC-0092-BC58-C508-239CA6A9A84F}"/>
-          </ac:spMkLst>
-        </pc:spChg>
-        <pc:grpChg chg="add del">
-          <ac:chgData name="Pablo Inzunza" userId="be16ff5b34c21876" providerId="LiveId" clId="{CC6937A5-FA4E-485C-A7D4-0E92CAEDBC02}" dt="2026-03-21T13:49:48.864" v="319" actId="165"/>
-          <ac:grpSpMkLst>
-            <pc:docMk/>
-            <pc:sldMk cId="315006707" sldId="259"/>
-            <ac:grpSpMk id="18" creationId="{15293861-804D-4902-202A-4F059A7981FD}"/>
-          </ac:grpSpMkLst>
-        </pc:grpChg>
         <pc:picChg chg="mod topLvl">
           <ac:chgData name="Pablo Inzunza" userId="be16ff5b34c21876" providerId="LiveId" clId="{CC6937A5-FA4E-485C-A7D4-0E92CAEDBC02}" dt="2026-03-21T13:49:48.864" v="319" actId="165"/>
           <ac:picMkLst>
             <pc:docMk/>
             <pc:sldMk cId="315006707" sldId="259"/>
             <ac:picMk id="4" creationId="{C989712D-2BB9-0543-3F3C-C500BEA7BFB9}"/>
-          </ac:picMkLst>
-        </pc:picChg>
-        <pc:picChg chg="del mod topLvl">
-          <ac:chgData name="Pablo Inzunza" userId="be16ff5b34c21876" providerId="LiveId" clId="{CC6937A5-FA4E-485C-A7D4-0E92CAEDBC02}" dt="2026-03-21T13:49:51.020" v="320" actId="478"/>
-          <ac:picMkLst>
-            <pc:docMk/>
-            <pc:sldMk cId="315006707" sldId="259"/>
-            <ac:picMk id="6" creationId="{8C91C574-6856-B273-0044-0652910EB494}"/>
-          </ac:picMkLst>
-        </pc:picChg>
-        <pc:picChg chg="add del mod">
-          <ac:chgData name="Pablo Inzunza" userId="be16ff5b34c21876" providerId="LiveId" clId="{CC6937A5-FA4E-485C-A7D4-0E92CAEDBC02}" dt="2026-03-21T16:31:11.599" v="1384" actId="478"/>
-          <ac:picMkLst>
-            <pc:docMk/>
-            <pc:sldMk cId="315006707" sldId="259"/>
-            <ac:picMk id="10" creationId="{FF956C1C-99F6-7F14-5F32-673D4674CA73}"/>
           </ac:picMkLst>
         </pc:picChg>
         <pc:cxnChg chg="mod">
@@ -1382,7 +902,7 @@
           <a:p>
             <a:fld id="{C1175F80-2F39-40DD-909D-7A02119CCA88}" type="datetimeFigureOut">
               <a:rPr lang="es-CL" smtClean="0"/>
-              <a:t>21-03-2026</a:t>
+              <a:t>27-03-2026</a:t>
             </a:fld>
             <a:endParaRPr lang="es-CL"/>
           </a:p>
@@ -1552,7 +1072,7 @@
           <a:p>
             <a:fld id="{C1175F80-2F39-40DD-909D-7A02119CCA88}" type="datetimeFigureOut">
               <a:rPr lang="es-CL" smtClean="0"/>
-              <a:t>21-03-2026</a:t>
+              <a:t>27-03-2026</a:t>
             </a:fld>
             <a:endParaRPr lang="es-CL"/>
           </a:p>
@@ -1732,7 +1252,7 @@
           <a:p>
             <a:fld id="{C1175F80-2F39-40DD-909D-7A02119CCA88}" type="datetimeFigureOut">
               <a:rPr lang="es-CL" smtClean="0"/>
-              <a:t>21-03-2026</a:t>
+              <a:t>27-03-2026</a:t>
             </a:fld>
             <a:endParaRPr lang="es-CL"/>
           </a:p>
@@ -1902,7 +1422,7 @@
           <a:p>
             <a:fld id="{C1175F80-2F39-40DD-909D-7A02119CCA88}" type="datetimeFigureOut">
               <a:rPr lang="es-CL" smtClean="0"/>
-              <a:t>21-03-2026</a:t>
+              <a:t>27-03-2026</a:t>
             </a:fld>
             <a:endParaRPr lang="es-CL"/>
           </a:p>
@@ -2148,7 +1668,7 @@
           <a:p>
             <a:fld id="{C1175F80-2F39-40DD-909D-7A02119CCA88}" type="datetimeFigureOut">
               <a:rPr lang="es-CL" smtClean="0"/>
-              <a:t>21-03-2026</a:t>
+              <a:t>27-03-2026</a:t>
             </a:fld>
             <a:endParaRPr lang="es-CL"/>
           </a:p>
@@ -2380,7 +1900,7 @@
           <a:p>
             <a:fld id="{C1175F80-2F39-40DD-909D-7A02119CCA88}" type="datetimeFigureOut">
               <a:rPr lang="es-CL" smtClean="0"/>
-              <a:t>21-03-2026</a:t>
+              <a:t>27-03-2026</a:t>
             </a:fld>
             <a:endParaRPr lang="es-CL"/>
           </a:p>
@@ -2747,7 +2267,7 @@
           <a:p>
             <a:fld id="{C1175F80-2F39-40DD-909D-7A02119CCA88}" type="datetimeFigureOut">
               <a:rPr lang="es-CL" smtClean="0"/>
-              <a:t>21-03-2026</a:t>
+              <a:t>27-03-2026</a:t>
             </a:fld>
             <a:endParaRPr lang="es-CL"/>
           </a:p>
@@ -2865,7 +2385,7 @@
           <a:p>
             <a:fld id="{C1175F80-2F39-40DD-909D-7A02119CCA88}" type="datetimeFigureOut">
               <a:rPr lang="es-CL" smtClean="0"/>
-              <a:t>21-03-2026</a:t>
+              <a:t>27-03-2026</a:t>
             </a:fld>
             <a:endParaRPr lang="es-CL"/>
           </a:p>
@@ -2960,7 +2480,7 @@
           <a:p>
             <a:fld id="{C1175F80-2F39-40DD-909D-7A02119CCA88}" type="datetimeFigureOut">
               <a:rPr lang="es-CL" smtClean="0"/>
-              <a:t>21-03-2026</a:t>
+              <a:t>27-03-2026</a:t>
             </a:fld>
             <a:endParaRPr lang="es-CL"/>
           </a:p>
@@ -3237,7 +2757,7 @@
           <a:p>
             <a:fld id="{C1175F80-2F39-40DD-909D-7A02119CCA88}" type="datetimeFigureOut">
               <a:rPr lang="es-CL" smtClean="0"/>
-              <a:t>21-03-2026</a:t>
+              <a:t>27-03-2026</a:t>
             </a:fld>
             <a:endParaRPr lang="es-CL"/>
           </a:p>
@@ -3494,7 +3014,7 @@
           <a:p>
             <a:fld id="{C1175F80-2F39-40DD-909D-7A02119CCA88}" type="datetimeFigureOut">
               <a:rPr lang="es-CL" smtClean="0"/>
-              <a:t>21-03-2026</a:t>
+              <a:t>27-03-2026</a:t>
             </a:fld>
             <a:endParaRPr lang="es-CL"/>
           </a:p>
@@ -3707,7 +3227,7 @@
           <a:p>
             <a:fld id="{C1175F80-2F39-40DD-909D-7A02119CCA88}" type="datetimeFigureOut">
               <a:rPr lang="es-CL" smtClean="0"/>
-              <a:t>21-03-2026</a:t>
+              <a:t>27-03-2026</a:t>
             </a:fld>
             <a:endParaRPr lang="es-CL"/>
           </a:p>
@@ -9510,7 +9030,7 @@
                 <a:latin typeface="DM Sans" pitchFamily="2" charset="0"/>
                 <a:cs typeface="Times New Roman" panose="02020603050405020304" pitchFamily="18" charset="0"/>
               </a:rPr>
-              <a:t>Fecha de referencia: 2025-08-11 </a:t>
+              <a:t>Fecha de referencia: 2022-02-24 </a:t>
             </a:r>
             <a:r>
               <a:rPr lang="es-CL" sz="1000" b="1" kern="100" dirty="0">
@@ -9564,7 +9084,7 @@
                 <a:latin typeface="DM Sans" pitchFamily="2" charset="0"/>
                 <a:cs typeface="Times New Roman" panose="02020603050405020304" pitchFamily="18" charset="0"/>
               </a:rPr>
-              <a:t>Fecha de referencia: 2022-02-24 </a:t>
+              <a:t>Fecha de referencia: 2025-08-11 </a:t>
             </a:r>
             <a:r>
               <a:rPr lang="es-CL" sz="1000" b="1" kern="100" dirty="0">

</xml_diff>

<commit_message>
Cambia cmg a USD/MWh
</commit_message>
<xml_diff>
--- a/data/processed/reports/reporte_generacion.pptx
+++ b/data/processed/reports/reporte_generacion.pptx
@@ -902,7 +902,7 @@
           <a:p>
             <a:fld id="{C1175F80-2F39-40DD-909D-7A02119CCA88}" type="datetimeFigureOut">
               <a:rPr lang="es-CL" smtClean="0"/>
-              <a:t>27-03-2026</a:t>
+              <a:t>31-03-2026</a:t>
             </a:fld>
             <a:endParaRPr lang="es-CL"/>
           </a:p>
@@ -1072,7 +1072,7 @@
           <a:p>
             <a:fld id="{C1175F80-2F39-40DD-909D-7A02119CCA88}" type="datetimeFigureOut">
               <a:rPr lang="es-CL" smtClean="0"/>
-              <a:t>27-03-2026</a:t>
+              <a:t>31-03-2026</a:t>
             </a:fld>
             <a:endParaRPr lang="es-CL"/>
           </a:p>
@@ -1252,7 +1252,7 @@
           <a:p>
             <a:fld id="{C1175F80-2F39-40DD-909D-7A02119CCA88}" type="datetimeFigureOut">
               <a:rPr lang="es-CL" smtClean="0"/>
-              <a:t>27-03-2026</a:t>
+              <a:t>31-03-2026</a:t>
             </a:fld>
             <a:endParaRPr lang="es-CL"/>
           </a:p>
@@ -1422,7 +1422,7 @@
           <a:p>
             <a:fld id="{C1175F80-2F39-40DD-909D-7A02119CCA88}" type="datetimeFigureOut">
               <a:rPr lang="es-CL" smtClean="0"/>
-              <a:t>27-03-2026</a:t>
+              <a:t>31-03-2026</a:t>
             </a:fld>
             <a:endParaRPr lang="es-CL"/>
           </a:p>
@@ -1668,7 +1668,7 @@
           <a:p>
             <a:fld id="{C1175F80-2F39-40DD-909D-7A02119CCA88}" type="datetimeFigureOut">
               <a:rPr lang="es-CL" smtClean="0"/>
-              <a:t>27-03-2026</a:t>
+              <a:t>31-03-2026</a:t>
             </a:fld>
             <a:endParaRPr lang="es-CL"/>
           </a:p>
@@ -1900,7 +1900,7 @@
           <a:p>
             <a:fld id="{C1175F80-2F39-40DD-909D-7A02119CCA88}" type="datetimeFigureOut">
               <a:rPr lang="es-CL" smtClean="0"/>
-              <a:t>27-03-2026</a:t>
+              <a:t>31-03-2026</a:t>
             </a:fld>
             <a:endParaRPr lang="es-CL"/>
           </a:p>
@@ -2267,7 +2267,7 @@
           <a:p>
             <a:fld id="{C1175F80-2F39-40DD-909D-7A02119CCA88}" type="datetimeFigureOut">
               <a:rPr lang="es-CL" smtClean="0"/>
-              <a:t>27-03-2026</a:t>
+              <a:t>31-03-2026</a:t>
             </a:fld>
             <a:endParaRPr lang="es-CL"/>
           </a:p>
@@ -2385,7 +2385,7 @@
           <a:p>
             <a:fld id="{C1175F80-2F39-40DD-909D-7A02119CCA88}" type="datetimeFigureOut">
               <a:rPr lang="es-CL" smtClean="0"/>
-              <a:t>27-03-2026</a:t>
+              <a:t>31-03-2026</a:t>
             </a:fld>
             <a:endParaRPr lang="es-CL"/>
           </a:p>
@@ -2480,7 +2480,7 @@
           <a:p>
             <a:fld id="{C1175F80-2F39-40DD-909D-7A02119CCA88}" type="datetimeFigureOut">
               <a:rPr lang="es-CL" smtClean="0"/>
-              <a:t>27-03-2026</a:t>
+              <a:t>31-03-2026</a:t>
             </a:fld>
             <a:endParaRPr lang="es-CL"/>
           </a:p>
@@ -2757,7 +2757,7 @@
           <a:p>
             <a:fld id="{C1175F80-2F39-40DD-909D-7A02119CCA88}" type="datetimeFigureOut">
               <a:rPr lang="es-CL" smtClean="0"/>
-              <a:t>27-03-2026</a:t>
+              <a:t>31-03-2026</a:t>
             </a:fld>
             <a:endParaRPr lang="es-CL"/>
           </a:p>
@@ -3014,7 +3014,7 @@
           <a:p>
             <a:fld id="{C1175F80-2F39-40DD-909D-7A02119CCA88}" type="datetimeFigureOut">
               <a:rPr lang="es-CL" smtClean="0"/>
-              <a:t>27-03-2026</a:t>
+              <a:t>31-03-2026</a:t>
             </a:fld>
             <a:endParaRPr lang="es-CL"/>
           </a:p>
@@ -3227,7 +3227,7 @@
           <a:p>
             <a:fld id="{C1175F80-2F39-40DD-909D-7A02119CCA88}" type="datetimeFigureOut">
               <a:rPr lang="es-CL" smtClean="0"/>
-              <a:t>27-03-2026</a:t>
+              <a:t>31-03-2026</a:t>
             </a:fld>
             <a:endParaRPr lang="es-CL"/>
           </a:p>
@@ -4064,7 +4064,7 @@
                 <a:solidFill>
                   <a:schemeClr val="bg1"/>
                 </a:solidFill>
-                <a:latin typeface="DM Sans" pitchFamily="2" charset="0"/>
+                <a:latin typeface="gobCL" pitchFamily="50" charset="0"/>
                 <a:ea typeface="Aptos" panose="020B0004020202020204" pitchFamily="34" charset="0"/>
                 <a:cs typeface="Times New Roman" panose="02020603050405020304" pitchFamily="18" charset="0"/>
               </a:rPr>
@@ -4074,7 +4074,7 @@
               <a:solidFill>
                 <a:schemeClr val="bg1"/>
               </a:solidFill>
-              <a:latin typeface="DM Sans" pitchFamily="2" charset="0"/>
+              <a:latin typeface="gobCL" pitchFamily="50" charset="0"/>
               <a:ea typeface="Aptos" panose="020B0004020202020204" pitchFamily="34" charset="0"/>
               <a:cs typeface="Times New Roman" panose="02020603050405020304" pitchFamily="18" charset="0"/>
             </a:endParaRPr>
@@ -4124,20 +4124,30 @@
                 <a:solidFill>
                   <a:srgbClr val="6FA3CC"/>
                 </a:solidFill>
+                <a:latin typeface="gobCL" pitchFamily="50" charset="0"/>
+                <a:cs typeface="Times New Roman" panose="02020603050405020304" pitchFamily="18" charset="0"/>
+              </a:rPr>
+              <a:t>Mes de estudio</a:t>
+            </a:r>
+            <a:r>
+              <a:rPr lang="es-CL" sz="1926" b="1" kern="100" dirty="0">
+                <a:solidFill>
+                  <a:srgbClr val="6FA3CC"/>
+                </a:solidFill>
                 <a:latin typeface="DM Sans" pitchFamily="2" charset="0"/>
                 <a:cs typeface="Times New Roman" panose="02020603050405020304" pitchFamily="18" charset="0"/>
               </a:rPr>
-              <a:t>Periodo de estudio: </a:t>
+              <a:t>2026-01</a:t>
             </a:r>
             <a:r>
               <a:rPr lang="es-CL" sz="1600" b="1" kern="100" dirty="0">
                 <a:solidFill>
                   <a:srgbClr val="6FA3CC"/>
                 </a:solidFill>
-                <a:latin typeface="DM Mono" panose="020B0509040201040103" pitchFamily="49" charset="0"/>
+                <a:latin typeface="Museo Sans 300" panose="02000000000000000000" pitchFamily="50" charset="0"/>
                 <a:cs typeface="Times New Roman" panose="02020603050405020304" pitchFamily="18" charset="0"/>
               </a:rPr>
-              <a:t>2025-02 → 2026-01</a:t>
+              <a:t>2025-01 → 2025-12</a:t>
             </a:r>
           </a:p>
         </p:txBody>
@@ -4411,7 +4421,7 @@
         <p:spPr>
           <a:xfrm>
             <a:off x="463919" y="4948946"/>
-            <a:ext cx="4788135" cy="5318059"/>
+            <a:ext cx="4788135" cy="4764061"/>
           </a:xfrm>
           <a:prstGeom prst="rect">
             <a:avLst/>
@@ -4446,18 +4456,18 @@
                 <a:solidFill>
                   <a:srgbClr val="2C2E38"/>
                 </a:solidFill>
-                <a:latin typeface="DM Sans" pitchFamily="2" charset="0"/>
+                <a:latin typeface="Museo Sans 300" panose="02000000000000000000" pitchFamily="50" charset="0"/>
                 <a:ea typeface="Calibri" panose="020F0502020204030204" pitchFamily="34" charset="0"/>
                 <a:cs typeface="Calibri" panose="020F0502020204030204" pitchFamily="34" charset="0"/>
               </a:rPr>
-              <a:t>El costo marginal promedio durante este período fue de 60,06 $/kWh, alcanzando su máximo de 97,18 $/kWh en 2025-02.</a:t>
+              <a:t>El costo marginal promedio durante este período fue de 63,10 $/kWh, alcanzando su máximo de 63,10 $/kWh en 2026-01.</a:t>
             </a:r>
             <a:r>
               <a:rPr lang="es-CL" sz="1200" b="1" dirty="0">
                 <a:solidFill>
                   <a:srgbClr val="2C2E38"/>
                 </a:solidFill>
-                <a:latin typeface="DM Sans" pitchFamily="2" charset="0"/>
+                <a:latin typeface="Museo Sans 300" panose="02000000000000000000" pitchFamily="50" charset="0"/>
                 <a:ea typeface="Calibri" panose="020F0502020204030204" pitchFamily="34" charset="0"/>
                 <a:cs typeface="Calibri" panose="020F0502020204030204" pitchFamily="34" charset="0"/>
               </a:rPr>
@@ -4468,40 +4478,40 @@
                 <a:solidFill>
                   <a:srgbClr val="2C2E38"/>
                 </a:solidFill>
-                <a:latin typeface="DM Sans" pitchFamily="2" charset="0"/>
+                <a:latin typeface="Museo Sans 300" panose="02000000000000000000" pitchFamily="50" charset="0"/>
                 <a:ea typeface="Calibri" panose="020F0502020204030204" pitchFamily="34" charset="0"/>
                 <a:cs typeface="Calibri" panose="020F0502020204030204" pitchFamily="34" charset="0"/>
               </a:rPr>
               <a:t/>
             </a:r>
             <a:r>
-              <a:rPr lang="es-CL" sz="1200" dirty="0">
+              <a:rPr lang="es-CL" sz="1200" dirty="0" err="1">
                 <a:solidFill>
                   <a:srgbClr val="2C2E38"/>
                 </a:solidFill>
-                <a:latin typeface="DM Mono" panose="020B0509040201040103" pitchFamily="49" charset="0"/>
+                <a:latin typeface="Museo Sans 300" panose="02000000000000000000" pitchFamily="50" charset="0"/>
                 <a:ea typeface="Calibri" panose="020F0502020204030204" pitchFamily="34" charset="0"/>
                 <a:cs typeface="Calibri" panose="020F0502020204030204" pitchFamily="34" charset="0"/>
               </a:rPr>
               <a:t/>
             </a:r>
             <a:r>
-              <a:rPr lang="es-CL" sz="1200" dirty="0" err="1">
+              <a:rPr lang="es-CL" sz="1200" dirty="0">
                 <a:solidFill>
                   <a:srgbClr val="2C2E38"/>
                 </a:solidFill>
-                <a:latin typeface="DM Mono" panose="020B0509040201040103" pitchFamily="49" charset="0"/>
+                <a:latin typeface="Museo Sans 300" panose="02000000000000000000" pitchFamily="50" charset="0"/>
                 <a:ea typeface="Calibri" panose="020F0502020204030204" pitchFamily="34" charset="0"/>
                 <a:cs typeface="Calibri" panose="020F0502020204030204" pitchFamily="34" charset="0"/>
               </a:rPr>
               <a:t/>
             </a:r>
             <a:r>
-              <a:rPr lang="es-CL" sz="1200" dirty="0">
+              <a:rPr lang="es-CL" sz="1200" dirty="0" err="1">
                 <a:solidFill>
                   <a:srgbClr val="2C2E38"/>
                 </a:solidFill>
-                <a:latin typeface="DM Mono" panose="020B0509040201040103" pitchFamily="49" charset="0"/>
+                <a:latin typeface="Museo Sans 300" panose="02000000000000000000" pitchFamily="50" charset="0"/>
                 <a:ea typeface="Calibri" panose="020F0502020204030204" pitchFamily="34" charset="0"/>
                 <a:cs typeface="Calibri" panose="020F0502020204030204" pitchFamily="34" charset="0"/>
               </a:rPr>
@@ -4512,84 +4522,29 @@
                 <a:solidFill>
                   <a:srgbClr val="2C2E38"/>
                 </a:solidFill>
-                <a:latin typeface="DM Sans" pitchFamily="2" charset="0"/>
+                <a:latin typeface="Museo Sans 300" panose="02000000000000000000" pitchFamily="50" charset="0"/>
                 <a:ea typeface="Calibri" panose="020F0502020204030204" pitchFamily="34" charset="0"/>
                 <a:cs typeface="Calibri" panose="020F0502020204030204" pitchFamily="34" charset="0"/>
               </a:rPr>
               <a:t/>
             </a:r>
             <a:r>
-              <a:rPr lang="es-CL" sz="1200" dirty="0">
+              <a:rPr lang="es-CL" sz="1200" dirty="0" err="1">
                 <a:solidFill>
                   <a:srgbClr val="2C2E38"/>
                 </a:solidFill>
-                <a:latin typeface="DM Mono" panose="020B0509040201040103" pitchFamily="49" charset="0"/>
+                <a:latin typeface="Museo Sans 300" panose="02000000000000000000" pitchFamily="50" charset="0"/>
                 <a:ea typeface="Calibri" panose="020F0502020204030204" pitchFamily="34" charset="0"/>
                 <a:cs typeface="Calibri" panose="020F0502020204030204" pitchFamily="34" charset="0"/>
               </a:rPr>
               <a:t/>
             </a:r>
             <a:r>
-              <a:rPr lang="es-CL" sz="1200" dirty="0" err="1">
+              <a:rPr lang="es-CL" sz="1200" dirty="0">
                 <a:solidFill>
                   <a:srgbClr val="2C2E38"/>
                 </a:solidFill>
-                <a:latin typeface="DM Mono" panose="020B0509040201040103" pitchFamily="49" charset="0"/>
-                <a:ea typeface="Calibri" panose="020F0502020204030204" pitchFamily="34" charset="0"/>
-                <a:cs typeface="Calibri" panose="020F0502020204030204" pitchFamily="34" charset="0"/>
-              </a:rPr>
-              <a:t/>
-            </a:r>
-            <a:r>
-              <a:rPr lang="es-CL" sz="1200" dirty="0">
-                <a:solidFill>
-                  <a:srgbClr val="2C2E38"/>
-                </a:solidFill>
-                <a:latin typeface="DM Mono" panose="020B0509040201040103" pitchFamily="49" charset="0"/>
-                <a:ea typeface="Calibri" panose="020F0502020204030204" pitchFamily="34" charset="0"/>
-                <a:cs typeface="Calibri" panose="020F0502020204030204" pitchFamily="34" charset="0"/>
-              </a:rPr>
-              <a:t/>
-            </a:r>
-            <a:r>
-              <a:rPr lang="es-CL" sz="1200" dirty="0">
-                <a:solidFill>
-                  <a:srgbClr val="2C2E38"/>
-                </a:solidFill>
-                <a:latin typeface="DM Sans" pitchFamily="2" charset="0"/>
-                <a:ea typeface="Calibri" panose="020F0502020204030204" pitchFamily="34" charset="0"/>
-                <a:cs typeface="Calibri" panose="020F0502020204030204" pitchFamily="34" charset="0"/>
-              </a:rPr>
-              <a:t/>
-            </a:r>
-            <a:r>
-              <a:rPr lang="es-CL" sz="1200" dirty="0">
-                <a:solidFill>
-                  <a:srgbClr val="2C2E38"/>
-                </a:solidFill>
-                <a:latin typeface="DM Mono" panose="020B0509040201040103" pitchFamily="49" charset="0"/>
-                <a:ea typeface="Calibri" panose="020F0502020204030204" pitchFamily="34" charset="0"/>
-                <a:cs typeface="Calibri" panose="020F0502020204030204" pitchFamily="34" charset="0"/>
-              </a:rPr>
-              <a:t/>
-            </a:r>
-            <a:r>
-              <a:rPr lang="es-CL" sz="1200" dirty="0" err="1">
-                <a:solidFill>
-                  <a:srgbClr val="2C2E38"/>
-                </a:solidFill>
-                <a:latin typeface="DM Mono" panose="020B0509040201040103" pitchFamily="49" charset="0"/>
-                <a:ea typeface="Calibri" panose="020F0502020204030204" pitchFamily="34" charset="0"/>
-                <a:cs typeface="Calibri" panose="020F0502020204030204" pitchFamily="34" charset="0"/>
-              </a:rPr>
-              <a:t/>
-            </a:r>
-            <a:r>
-              <a:rPr lang="es-CL" sz="1200" dirty="0">
-                <a:solidFill>
-                  <a:srgbClr val="2C2E38"/>
-                </a:solidFill>
-                <a:latin typeface="DM Mono" panose="020B0509040201040103" pitchFamily="49" charset="0"/>
+                <a:latin typeface="Museo Sans 300" panose="02000000000000000000" pitchFamily="50" charset="0"/>
                 <a:ea typeface="Calibri" panose="020F0502020204030204" pitchFamily="34" charset="0"/>
                 <a:cs typeface="Calibri" panose="020F0502020204030204" pitchFamily="34" charset="0"/>
               </a:rPr>
@@ -4607,7 +4562,7 @@
                 <a:solidFill>
                   <a:srgbClr val="2C2E38"/>
                 </a:solidFill>
-                <a:latin typeface="DM Sans" pitchFamily="2" charset="0"/>
+                <a:latin typeface="Museo Sans 300" panose="02000000000000000000" pitchFamily="50" charset="0"/>
                 <a:ea typeface="Calibri" panose="020F0502020204030204" pitchFamily="34" charset="0"/>
                 <a:cs typeface="Calibri" panose="020F0502020204030204" pitchFamily="34" charset="0"/>
               </a:rPr>
@@ -4625,18 +4580,18 @@
                 <a:solidFill>
                   <a:srgbClr val="2C2E38"/>
                 </a:solidFill>
-                <a:latin typeface="DM Sans" pitchFamily="2" charset="0"/>
+                <a:latin typeface="Museo Sans 300" panose="02000000000000000000" pitchFamily="50" charset="0"/>
                 <a:ea typeface="Calibri" panose="020F0502020204030204" pitchFamily="34" charset="0"/>
                 <a:cs typeface="Calibri" panose="020F0502020204030204" pitchFamily="34" charset="0"/>
               </a:rPr>
-              <a:t>El promedio de spread CMg entre horas solares y no solares registró un máximo de 59,83 $/kWh en la barra Crucero 220kV , mientras que en la barra Puerto Montt 220kV el valor ascendió a 2,51 $/kWh. Esta última barra presenta la mayor variabilidad estacional de costos marginales, donde meses con baja disponibilidad de recurso hídrico presentan desacoples económicos y costos mayores respecto de otras zonas del país. </a:t>
+              <a:t>El promedio de spread CMg entre horas solares y no solares registró un máximo de 61,03 $/kWh en la barra Crucero 220kV , mientras que en la barra Puerto Montt 220kV el valor ascendió a 50,39 $/kWh. Esta última barra presenta la mayor variabilidad estacional de costos marginales, donde meses con baja disponibilidad de recurso hídrico presentan desacoples económicos y costos mayores respecto de otras zonas del país. </a:t>
             </a:r>
             <a:r>
               <a:rPr lang="es-CL" sz="1200" b="1" dirty="0">
                 <a:solidFill>
                   <a:srgbClr val="2C2E38"/>
                 </a:solidFill>
-                <a:latin typeface="DM Sans" pitchFamily="2" charset="0"/>
+                <a:latin typeface="Museo Sans 300" panose="02000000000000000000" pitchFamily="50" charset="0"/>
                 <a:ea typeface="Calibri" panose="020F0502020204030204" pitchFamily="34" charset="0"/>
                 <a:cs typeface="Calibri" panose="020F0502020204030204" pitchFamily="34" charset="0"/>
               </a:rPr>
@@ -4647,7 +4602,7 @@
                 <a:solidFill>
                   <a:srgbClr val="2C2E38"/>
                 </a:solidFill>
-                <a:latin typeface="DM Sans" pitchFamily="2" charset="0"/>
+                <a:latin typeface="Museo Sans 300" panose="02000000000000000000" pitchFamily="50" charset="0"/>
                 <a:ea typeface="Calibri" panose="020F0502020204030204" pitchFamily="34" charset="0"/>
                 <a:cs typeface="Calibri" panose="020F0502020204030204" pitchFamily="34" charset="0"/>
               </a:rPr>
@@ -4658,7 +4613,7 @@
                 <a:solidFill>
                   <a:srgbClr val="2C2E38"/>
                 </a:solidFill>
-                <a:latin typeface="DM Sans" pitchFamily="2" charset="0"/>
+                <a:latin typeface="Museo Sans 300" panose="02000000000000000000" pitchFamily="50" charset="0"/>
                 <a:ea typeface="Calibri" panose="020F0502020204030204" pitchFamily="34" charset="0"/>
                 <a:cs typeface="Calibri" panose="020F0502020204030204" pitchFamily="34" charset="0"/>
               </a:rPr>
@@ -4669,40 +4624,40 @@
                 <a:solidFill>
                   <a:srgbClr val="2C2E38"/>
                 </a:solidFill>
-                <a:latin typeface="DM Sans" pitchFamily="2" charset="0"/>
+                <a:latin typeface="Museo Sans 300" panose="02000000000000000000" pitchFamily="50" charset="0"/>
                 <a:ea typeface="Calibri" panose="020F0502020204030204" pitchFamily="34" charset="0"/>
                 <a:cs typeface="Calibri" panose="020F0502020204030204" pitchFamily="34" charset="0"/>
               </a:rPr>
               <a:t/>
             </a:r>
             <a:r>
-              <a:rPr lang="es-CL" sz="1200" dirty="0">
+              <a:rPr lang="es-CL" sz="1200" dirty="0" err="1">
                 <a:solidFill>
                   <a:srgbClr val="2C2E38"/>
                 </a:solidFill>
-                <a:latin typeface="DM Mono" panose="020B0509040201040103" pitchFamily="49" charset="0"/>
+                <a:latin typeface="Museo Sans 300" panose="02000000000000000000" pitchFamily="50" charset="0"/>
                 <a:ea typeface="Calibri" panose="020F0502020204030204" pitchFamily="34" charset="0"/>
                 <a:cs typeface="Calibri" panose="020F0502020204030204" pitchFamily="34" charset="0"/>
               </a:rPr>
               <a:t/>
             </a:r>
             <a:r>
-              <a:rPr lang="es-CL" sz="1200" dirty="0" err="1">
+              <a:rPr lang="es-CL" sz="1200" dirty="0">
                 <a:solidFill>
                   <a:srgbClr val="2C2E38"/>
                 </a:solidFill>
-                <a:latin typeface="DM Mono" panose="020B0509040201040103" pitchFamily="49" charset="0"/>
+                <a:latin typeface="Museo Sans 300" panose="02000000000000000000" pitchFamily="50" charset="0"/>
                 <a:ea typeface="Calibri" panose="020F0502020204030204" pitchFamily="34" charset="0"/>
                 <a:cs typeface="Calibri" panose="020F0502020204030204" pitchFamily="34" charset="0"/>
               </a:rPr>
               <a:t/>
             </a:r>
             <a:r>
-              <a:rPr lang="es-CL" sz="1200" dirty="0">
+              <a:rPr lang="es-CL" sz="1200" dirty="0" err="1">
                 <a:solidFill>
                   <a:srgbClr val="2C2E38"/>
                 </a:solidFill>
-                <a:latin typeface="DM Mono" panose="020B0509040201040103" pitchFamily="49" charset="0"/>
+                <a:latin typeface="Museo Sans 300" panose="02000000000000000000" pitchFamily="50" charset="0"/>
                 <a:ea typeface="Calibri" panose="020F0502020204030204" pitchFamily="34" charset="0"/>
                 <a:cs typeface="Calibri" panose="020F0502020204030204" pitchFamily="34" charset="0"/>
               </a:rPr>
@@ -4713,51 +4668,7 @@
                 <a:solidFill>
                   <a:srgbClr val="2C2E38"/>
                 </a:solidFill>
-                <a:latin typeface="DM Sans" pitchFamily="2" charset="0"/>
-                <a:ea typeface="Calibri" panose="020F0502020204030204" pitchFamily="34" charset="0"/>
-                <a:cs typeface="Calibri" panose="020F0502020204030204" pitchFamily="34" charset="0"/>
-              </a:rPr>
-              <a:t/>
-            </a:r>
-            <a:r>
-              <a:rPr lang="es-CL" sz="1200" dirty="0">
-                <a:solidFill>
-                  <a:srgbClr val="2C2E38"/>
-                </a:solidFill>
-                <a:latin typeface="DM Mono" panose="020B0509040201040103" pitchFamily="49" charset="0"/>
-                <a:ea typeface="Calibri" panose="020F0502020204030204" pitchFamily="34" charset="0"/>
-                <a:cs typeface="Calibri" panose="020F0502020204030204" pitchFamily="34" charset="0"/>
-              </a:rPr>
-              <a:t/>
-            </a:r>
-            <a:r>
-              <a:rPr lang="es-CL" sz="1200" dirty="0" err="1">
-                <a:solidFill>
-                  <a:srgbClr val="2C2E38"/>
-                </a:solidFill>
-                <a:latin typeface="DM Mono" panose="020B0509040201040103" pitchFamily="49" charset="0"/>
-                <a:ea typeface="Calibri" panose="020F0502020204030204" pitchFamily="34" charset="0"/>
-                <a:cs typeface="Calibri" panose="020F0502020204030204" pitchFamily="34" charset="0"/>
-              </a:rPr>
-              <a:t/>
-            </a:r>
-            <a:r>
-              <a:rPr lang="es-CL" sz="1200" dirty="0">
-                <a:solidFill>
-                  <a:srgbClr val="2C2E38"/>
-                </a:solidFill>
-                <a:latin typeface="DM Mono" panose="020B0509040201040103" pitchFamily="49" charset="0"/>
-                <a:ea typeface="Calibri" panose="020F0502020204030204" pitchFamily="34" charset="0"/>
-                <a:cs typeface="Calibri" panose="020F0502020204030204" pitchFamily="34" charset="0"/>
-              </a:rPr>
-              <a:t/>
-            </a:r>
-            <a:r>
-              <a:rPr lang="es-CL" sz="1200" dirty="0">
-                <a:solidFill>
-                  <a:srgbClr val="2C2E38"/>
-                </a:solidFill>
-                <a:latin typeface="DM Sans" pitchFamily="2" charset="0"/>
+                <a:latin typeface="Museo Sans 300" panose="02000000000000000000" pitchFamily="50" charset="0"/>
                 <a:ea typeface="Calibri" panose="020F0502020204030204" pitchFamily="34" charset="0"/>
                 <a:cs typeface="Calibri" panose="020F0502020204030204" pitchFamily="34" charset="0"/>
               </a:rPr>
@@ -4875,7 +4786,7 @@
                 <a:solidFill>
                   <a:srgbClr val="002060"/>
                 </a:solidFill>
-                <a:latin typeface="DM Sans" pitchFamily="2" charset="0"/>
+                <a:latin typeface="gobCL" pitchFamily="50" charset="0"/>
                 <a:cs typeface="Times New Roman" panose="02020603050405020304" pitchFamily="18" charset="0"/>
               </a:rPr>
               <a:t>INDICADORES CLAVE</a:t>
@@ -4884,7 +4795,7 @@
               <a:solidFill>
                 <a:srgbClr val="002060"/>
               </a:solidFill>
-              <a:latin typeface="DM Sans" pitchFamily="2" charset="0"/>
+              <a:latin typeface="gobCL" pitchFamily="50" charset="0"/>
               <a:cs typeface="Times New Roman" panose="02020603050405020304" pitchFamily="18" charset="0"/>
             </a:endParaRPr>
           </a:p>
@@ -4950,7 +4861,7 @@
         <p:spPr>
           <a:xfrm>
             <a:off x="5610453" y="4948946"/>
-            <a:ext cx="4427082" cy="3801041"/>
+            <a:ext cx="4427082" cy="3524042"/>
           </a:xfrm>
           <a:prstGeom prst="rect">
             <a:avLst/>
@@ -4980,18 +4891,18 @@
                 <a:solidFill>
                   <a:srgbClr val="2C2E38"/>
                 </a:solidFill>
-                <a:latin typeface="DM Sans" pitchFamily="2" charset="0"/>
+                <a:latin typeface="Museo Sans 300" panose="02000000000000000000" pitchFamily="50" charset="0"/>
                 <a:ea typeface="Calibri" panose="020F0502020204030204" pitchFamily="34" charset="0"/>
                 <a:cs typeface="Calibri" panose="020F0502020204030204" pitchFamily="34" charset="0"/>
               </a:rPr>
-              <a:t>Entre enero y diciembre de 2025, la energía renovable total reducida asciende a 5.542.017 MWh, destacando el caso de la central solar Ceme 1, que redujo sus inyecciones en un total de 230.326 MWh durante el periodo de estudio. </a:t>
+              <a:t>Entre enero y diciembre de 2025, la energía renovable total reducida asciende a 785.848 MWh, destacando el caso de la central solar Guanchoi, que redujo sus inyecciones en un total de 57.372 MWh durante el periodo de estudio. </a:t>
             </a:r>
             <a:r>
               <a:rPr lang="es-CL" sz="1200" b="1" dirty="0">
                 <a:solidFill>
                   <a:srgbClr val="2C2E38"/>
                 </a:solidFill>
-                <a:latin typeface="DM Sans" pitchFamily="2" charset="0"/>
+                <a:latin typeface="Museo Sans 300" panose="02000000000000000000" pitchFamily="50" charset="0"/>
                 <a:ea typeface="Calibri" panose="020F0502020204030204" pitchFamily="34" charset="0"/>
                 <a:cs typeface="Calibri" panose="020F0502020204030204" pitchFamily="34" charset="0"/>
               </a:rPr>
@@ -5002,62 +4913,62 @@
                 <a:solidFill>
                   <a:srgbClr val="2C2E38"/>
                 </a:solidFill>
-                <a:latin typeface="DM Sans" pitchFamily="2" charset="0"/>
+                <a:latin typeface="Museo Sans 300" panose="02000000000000000000" pitchFamily="50" charset="0"/>
                 <a:ea typeface="Calibri" panose="020F0502020204030204" pitchFamily="34" charset="0"/>
                 <a:cs typeface="Calibri" panose="020F0502020204030204" pitchFamily="34" charset="0"/>
               </a:rPr>
               <a:t/>
             </a:r>
             <a:r>
-              <a:rPr lang="es-CL" sz="1200" dirty="0">
+              <a:rPr lang="es-CL" sz="1200" dirty="0" err="1">
                 <a:solidFill>
                   <a:srgbClr val="2C2E38"/>
                 </a:solidFill>
-                <a:latin typeface="DM Mono" panose="020B0509040201040103" pitchFamily="49" charset="0"/>
+                <a:latin typeface="Museo Sans 300" panose="02000000000000000000" pitchFamily="50" charset="0"/>
                 <a:ea typeface="Calibri" panose="020F0502020204030204" pitchFamily="34" charset="0"/>
                 <a:cs typeface="Calibri" panose="020F0502020204030204" pitchFamily="34" charset="0"/>
               </a:rPr>
               <a:t/>
             </a:r>
             <a:r>
-              <a:rPr lang="es-CL" sz="1200" dirty="0" err="1">
+              <a:rPr lang="es-CL" sz="1200" dirty="0">
                 <a:solidFill>
                   <a:srgbClr val="2C2E38"/>
                 </a:solidFill>
-                <a:latin typeface="DM Mono" panose="020B0509040201040103" pitchFamily="49" charset="0"/>
+                <a:latin typeface="Museo Sans 300" panose="02000000000000000000" pitchFamily="50" charset="0"/>
                 <a:ea typeface="Calibri" panose="020F0502020204030204" pitchFamily="34" charset="0"/>
                 <a:cs typeface="Calibri" panose="020F0502020204030204" pitchFamily="34" charset="0"/>
               </a:rPr>
               <a:t/>
             </a:r>
             <a:r>
-              <a:rPr lang="es-CL" sz="1200" dirty="0">
+              <a:rPr lang="es-CL" sz="1200" dirty="0" err="1">
                 <a:solidFill>
                   <a:srgbClr val="2C2E38"/>
                 </a:solidFill>
-                <a:latin typeface="DM Mono" panose="020B0509040201040103" pitchFamily="49" charset="0"/>
+                <a:latin typeface="Museo Sans 300" panose="02000000000000000000" pitchFamily="50" charset="0"/>
                 <a:ea typeface="Calibri" panose="020F0502020204030204" pitchFamily="34" charset="0"/>
                 <a:cs typeface="Calibri" panose="020F0502020204030204" pitchFamily="34" charset="0"/>
               </a:rPr>
               <a:t/>
             </a:r>
             <a:r>
-              <a:rPr lang="es-CL" sz="1200" dirty="0" err="1">
+              <a:rPr lang="es-CL" sz="1200" dirty="0">
                 <a:solidFill>
                   <a:srgbClr val="2C2E38"/>
                 </a:solidFill>
-                <a:latin typeface="DM Sans" pitchFamily="2" charset="0"/>
+                <a:latin typeface="Museo Sans 300" panose="02000000000000000000" pitchFamily="50" charset="0"/>
                 <a:ea typeface="Calibri" panose="020F0502020204030204" pitchFamily="34" charset="0"/>
                 <a:cs typeface="Calibri" panose="020F0502020204030204" pitchFamily="34" charset="0"/>
               </a:rPr>
               <a:t/>
             </a:r>
             <a:r>
-              <a:rPr lang="es-CL" sz="1200" dirty="0">
+              <a:rPr lang="es-CL" sz="1200" dirty="0" err="1">
                 <a:solidFill>
                   <a:srgbClr val="2C2E38"/>
                 </a:solidFill>
-                <a:latin typeface="DM Sans" pitchFamily="2" charset="0"/>
+                <a:latin typeface="Museo Sans 300" panose="02000000000000000000" pitchFamily="50" charset="0"/>
                 <a:ea typeface="Calibri" panose="020F0502020204030204" pitchFamily="34" charset="0"/>
                 <a:cs typeface="Calibri" panose="020F0502020204030204" pitchFamily="34" charset="0"/>
               </a:rPr>
@@ -5068,7 +4979,7 @@
                 <a:solidFill>
                   <a:srgbClr val="2C2E38"/>
                 </a:solidFill>
-                <a:latin typeface="DM Mono" panose="020B0509040201040103" pitchFamily="49" charset="0"/>
+                <a:latin typeface="Museo Sans 300" panose="02000000000000000000" pitchFamily="50" charset="0"/>
                 <a:ea typeface="Calibri" panose="020F0502020204030204" pitchFamily="34" charset="0"/>
                 <a:cs typeface="Calibri" panose="020F0502020204030204" pitchFamily="34" charset="0"/>
               </a:rPr>
@@ -5079,7 +4990,7 @@
                 <a:solidFill>
                   <a:srgbClr val="2C2E38"/>
                 </a:solidFill>
-                <a:latin typeface="DM Mono" panose="020B0509040201040103" pitchFamily="49" charset="0"/>
+                <a:latin typeface="Museo Sans 300" panose="02000000000000000000" pitchFamily="50" charset="0"/>
                 <a:ea typeface="Calibri" panose="020F0502020204030204" pitchFamily="34" charset="0"/>
                 <a:cs typeface="Calibri" panose="020F0502020204030204" pitchFamily="34" charset="0"/>
               </a:rPr>
@@ -5090,62 +5001,7 @@
                 <a:solidFill>
                   <a:srgbClr val="2C2E38"/>
                 </a:solidFill>
-                <a:latin typeface="DM Mono" panose="020B0509040201040103" pitchFamily="49" charset="0"/>
-                <a:ea typeface="Calibri" panose="020F0502020204030204" pitchFamily="34" charset="0"/>
-                <a:cs typeface="Calibri" panose="020F0502020204030204" pitchFamily="34" charset="0"/>
-              </a:rPr>
-              <a:t/>
-            </a:r>
-            <a:r>
-              <a:rPr lang="es-CL" sz="1200" dirty="0">
-                <a:solidFill>
-                  <a:srgbClr val="2C2E38"/>
-                </a:solidFill>
-                <a:latin typeface="DM Sans" pitchFamily="2" charset="0"/>
-                <a:ea typeface="Calibri" panose="020F0502020204030204" pitchFamily="34" charset="0"/>
-                <a:cs typeface="Calibri" panose="020F0502020204030204" pitchFamily="34" charset="0"/>
-              </a:rPr>
-              <a:t/>
-            </a:r>
-            <a:r>
-              <a:rPr lang="es-CL" sz="1200" dirty="0">
-                <a:solidFill>
-                  <a:srgbClr val="2C2E38"/>
-                </a:solidFill>
-                <a:latin typeface="DM Mono" panose="020B0509040201040103" pitchFamily="49" charset="0"/>
-                <a:ea typeface="Calibri" panose="020F0502020204030204" pitchFamily="34" charset="0"/>
-                <a:cs typeface="Calibri" panose="020F0502020204030204" pitchFamily="34" charset="0"/>
-              </a:rPr>
-              <a:t/>
-            </a:r>
-            <a:r>
-              <a:rPr lang="es-CL" sz="1200" dirty="0" err="1">
-                <a:solidFill>
-                  <a:srgbClr val="2C2E38"/>
-                </a:solidFill>
-                <a:latin typeface="DM Mono" panose="020B0509040201040103" pitchFamily="49" charset="0"/>
-                <a:ea typeface="Calibri" panose="020F0502020204030204" pitchFamily="34" charset="0"/>
-                <a:cs typeface="Calibri" panose="020F0502020204030204" pitchFamily="34" charset="0"/>
-              </a:rPr>
-              <a:t/>
-            </a:r>
-            <a:r>
-              <a:rPr lang="es-CL" sz="1200" dirty="0">
-                <a:solidFill>
-                  <a:srgbClr val="2C2E38"/>
-                </a:solidFill>
-                <a:latin typeface="DM Mono" panose="020B0509040201040103" pitchFamily="49" charset="0"/>
-                <a:ea typeface="Calibri" panose="020F0502020204030204" pitchFamily="34" charset="0"/>
-                <a:cs typeface="Calibri" panose="020F0502020204030204" pitchFamily="34" charset="0"/>
-              </a:rPr>
-              <a:t/>
-            </a:r>
-            <a:r>
-              <a:rPr lang="es-CL" sz="1200" dirty="0">
-                <a:solidFill>
-                  <a:srgbClr val="2C2E38"/>
-                </a:solidFill>
-                <a:latin typeface="DM Sans" pitchFamily="2" charset="0"/>
+                <a:latin typeface="Museo Sans 300" panose="02000000000000000000" pitchFamily="50" charset="0"/>
                 <a:ea typeface="Calibri" panose="020F0502020204030204" pitchFamily="34" charset="0"/>
                 <a:cs typeface="Calibri" panose="020F0502020204030204" pitchFamily="34" charset="0"/>
               </a:rPr>
@@ -5162,7 +5018,7 @@
               <a:solidFill>
                 <a:srgbClr val="2C2E38"/>
               </a:solidFill>
-              <a:latin typeface="DM Sans" pitchFamily="2" charset="0"/>
+              <a:latin typeface="Museo Sans 300" panose="02000000000000000000" pitchFamily="50" charset="0"/>
               <a:ea typeface="Calibri" panose="020F0502020204030204" pitchFamily="34" charset="0"/>
               <a:cs typeface="Calibri" panose="020F0502020204030204" pitchFamily="34" charset="0"/>
             </a:endParaRPr>
@@ -5178,7 +5034,7 @@
                 <a:solidFill>
                   <a:srgbClr val="2C2E38"/>
                 </a:solidFill>
-                <a:latin typeface="DM Sans" pitchFamily="2" charset="0"/>
+                <a:latin typeface="Museo Sans 300" panose="02000000000000000000" pitchFamily="50" charset="0"/>
                 <a:ea typeface="Calibri" panose="020F0502020204030204" pitchFamily="34" charset="0"/>
                 <a:cs typeface="Calibri" panose="020F0502020204030204" pitchFamily="34" charset="0"/>
               </a:rPr>
@@ -5293,18 +5149,18 @@
                 <a:solidFill>
                   <a:srgbClr val="2C2E38"/>
                 </a:solidFill>
-                <a:latin typeface="DM Mono" panose="020B0509040201040103" pitchFamily="49" charset="0"/>
+                <a:latin typeface="Museo Sans 500" panose="02000000000000000000" pitchFamily="50" charset="0"/>
                 <a:ea typeface="Calibri" panose="020F0502020204030204" pitchFamily="34" charset="0"/>
                 <a:cs typeface="Calibri" panose="020F0502020204030204" pitchFamily="34" charset="0"/>
               </a:rPr>
-              <a:t>60,06 $/kWh</a:t>
+              <a:t>63,10 $/kWh</a:t>
             </a:r>
             <a:r>
               <a:rPr lang="es-CL" b="1" dirty="0" err="1">
                 <a:solidFill>
                   <a:srgbClr val="2C2E38"/>
                 </a:solidFill>
-                <a:latin typeface="DM Mono" panose="020B0509040201040103" pitchFamily="49" charset="0"/>
+                <a:latin typeface="Museo Sans 500" panose="02000000000000000000" pitchFamily="50" charset="0"/>
                 <a:ea typeface="Calibri" panose="020F0502020204030204" pitchFamily="34" charset="0"/>
                 <a:cs typeface="Calibri" panose="020F0502020204030204" pitchFamily="34" charset="0"/>
               </a:rPr>
@@ -5315,7 +5171,7 @@
                 <a:solidFill>
                   <a:srgbClr val="2C2E38"/>
                 </a:solidFill>
-                <a:latin typeface="DM Mono" panose="020B0509040201040103" pitchFamily="49" charset="0"/>
+                <a:latin typeface="Museo Sans 500" panose="02000000000000000000" pitchFamily="50" charset="0"/>
                 <a:ea typeface="Calibri" panose="020F0502020204030204" pitchFamily="34" charset="0"/>
                 <a:cs typeface="Calibri" panose="020F0502020204030204" pitchFamily="34" charset="0"/>
               </a:rPr>
@@ -5341,7 +5197,7 @@
         <p:spPr>
           <a:xfrm>
             <a:off x="3104307" y="3793619"/>
-            <a:ext cx="2161743" cy="923330"/>
+            <a:ext cx="2161743" cy="646331"/>
           </a:xfrm>
           <a:prstGeom prst="rect">
             <a:avLst/>
@@ -5359,18 +5215,18 @@
                 <a:solidFill>
                   <a:srgbClr val="2C2E38"/>
                 </a:solidFill>
-                <a:latin typeface="DM Mono" panose="020B0509040201040103" pitchFamily="49" charset="0"/>
+                <a:latin typeface="Museo Sans 500" panose="02000000000000000000" pitchFamily="50" charset="0"/>
                 <a:ea typeface="Calibri" panose="020F0502020204030204" pitchFamily="34" charset="0"/>
                 <a:cs typeface="Calibri" panose="020F0502020204030204" pitchFamily="34" charset="0"/>
               </a:rPr>
-              <a:t>59,83 $/kWh</a:t>
+              <a:t>61,03 $/kWh</a:t>
             </a:r>
             <a:r>
               <a:rPr lang="es-CL" b="1" dirty="0" err="1">
                 <a:solidFill>
                   <a:srgbClr val="2C2E38"/>
                 </a:solidFill>
-                <a:latin typeface="DM Mono" panose="020B0509040201040103" pitchFamily="49" charset="0"/>
+                <a:latin typeface="Museo Sans 500" panose="02000000000000000000" pitchFamily="50" charset="0"/>
                 <a:ea typeface="Calibri" panose="020F0502020204030204" pitchFamily="34" charset="0"/>
                 <a:cs typeface="Calibri" panose="020F0502020204030204" pitchFamily="34" charset="0"/>
               </a:rPr>
@@ -5381,7 +5237,7 @@
                 <a:solidFill>
                   <a:srgbClr val="2C2E38"/>
                 </a:solidFill>
-                <a:latin typeface="DM Mono" panose="020B0509040201040103" pitchFamily="49" charset="0"/>
+                <a:latin typeface="Museo Sans 500" panose="02000000000000000000" pitchFamily="50" charset="0"/>
                 <a:ea typeface="Calibri" panose="020F0502020204030204" pitchFamily="34" charset="0"/>
                 <a:cs typeface="Calibri" panose="020F0502020204030204" pitchFamily="34" charset="0"/>
               </a:rPr>
@@ -5425,18 +5281,18 @@
                 <a:solidFill>
                   <a:srgbClr val="2C2E38"/>
                 </a:solidFill>
-                <a:latin typeface="DM Mono" panose="020B0509040201040103" pitchFamily="49" charset="0"/>
+                <a:latin typeface="Museo Sans 500" panose="02000000000000000000" pitchFamily="50" charset="0"/>
                 <a:ea typeface="Calibri" panose="020F0502020204030204" pitchFamily="34" charset="0"/>
                 <a:cs typeface="Calibri" panose="020F0502020204030204" pitchFamily="34" charset="0"/>
               </a:rPr>
-              <a:t>5.542.017 MWh</a:t>
+              <a:t>785.848 MWh</a:t>
             </a:r>
             <a:r>
               <a:rPr lang="es-CL" b="1" dirty="0" err="1">
                 <a:solidFill>
                   <a:srgbClr val="2C2E38"/>
                 </a:solidFill>
-                <a:latin typeface="DM Mono" panose="020B0509040201040103" pitchFamily="49" charset="0"/>
+                <a:latin typeface="Museo Sans 500" panose="02000000000000000000" pitchFamily="50" charset="0"/>
                 <a:ea typeface="Calibri" panose="020F0502020204030204" pitchFamily="34" charset="0"/>
                 <a:cs typeface="Calibri" panose="020F0502020204030204" pitchFamily="34" charset="0"/>
               </a:rPr>
@@ -5447,7 +5303,7 @@
                 <a:solidFill>
                   <a:srgbClr val="2C2E38"/>
                 </a:solidFill>
-                <a:latin typeface="DM Mono" panose="020B0509040201040103" pitchFamily="49" charset="0"/>
+                <a:latin typeface="Museo Sans 500" panose="02000000000000000000" pitchFamily="50" charset="0"/>
                 <a:ea typeface="Calibri" panose="020F0502020204030204" pitchFamily="34" charset="0"/>
                 <a:cs typeface="Calibri" panose="020F0502020204030204" pitchFamily="34" charset="0"/>
               </a:rPr>
@@ -5473,7 +5329,7 @@
         <p:spPr>
           <a:xfrm>
             <a:off x="8050444" y="3726784"/>
-            <a:ext cx="2161743" cy="923330"/>
+            <a:ext cx="2161743" cy="646331"/>
           </a:xfrm>
           <a:prstGeom prst="rect">
             <a:avLst/>
@@ -5491,18 +5347,18 @@
                 <a:solidFill>
                   <a:srgbClr val="2C2E38"/>
                 </a:solidFill>
-                <a:latin typeface="DM Mono" panose="020B0509040201040103" pitchFamily="49" charset="0"/>
+                <a:latin typeface="Museo Sans 500" panose="02000000000000000000" pitchFamily="50" charset="0"/>
                 <a:ea typeface="Calibri" panose="020F0502020204030204" pitchFamily="34" charset="0"/>
                 <a:cs typeface="Calibri" panose="020F0502020204030204" pitchFamily="34" charset="0"/>
               </a:rPr>
-              <a:t>230.326 MWh</a:t>
+              <a:t>57.372 MWh</a:t>
             </a:r>
             <a:r>
               <a:rPr lang="es-CL" b="1" dirty="0" err="1">
                 <a:solidFill>
                   <a:srgbClr val="2C2E38"/>
                 </a:solidFill>
-                <a:latin typeface="DM Mono" panose="020B0509040201040103" pitchFamily="49" charset="0"/>
+                <a:latin typeface="Museo Sans 500" panose="02000000000000000000" pitchFamily="50" charset="0"/>
                 <a:ea typeface="Calibri" panose="020F0502020204030204" pitchFamily="34" charset="0"/>
                 <a:cs typeface="Calibri" panose="020F0502020204030204" pitchFamily="34" charset="0"/>
               </a:rPr>
@@ -5513,7 +5369,7 @@
                 <a:solidFill>
                   <a:srgbClr val="2C2E38"/>
                 </a:solidFill>
-                <a:latin typeface="DM Mono" panose="020B0509040201040103" pitchFamily="49" charset="0"/>
+                <a:latin typeface="Museo Sans 500" panose="02000000000000000000" pitchFamily="50" charset="0"/>
                 <a:ea typeface="Calibri" panose="020F0502020204030204" pitchFamily="34" charset="0"/>
                 <a:cs typeface="Calibri" panose="020F0502020204030204" pitchFamily="34" charset="0"/>
               </a:rPr>
@@ -5606,7 +5462,7 @@
         <p:spPr>
           <a:xfrm>
             <a:off x="586802" y="1321902"/>
-            <a:ext cx="9518204" cy="1425840"/>
+            <a:ext cx="9518204" cy="1396664"/>
           </a:xfrm>
           <a:prstGeom prst="rect">
             <a:avLst/>
@@ -5635,7 +5491,7 @@
                 <a:solidFill>
                   <a:srgbClr val="E67E22"/>
                 </a:solidFill>
-                <a:latin typeface="DM Sans" pitchFamily="2" charset="0"/>
+                <a:latin typeface="Museo Sans 300" panose="02000000000000000000" pitchFamily="50" charset="0"/>
                 <a:ea typeface="Calibri" panose="020F0502020204030204" pitchFamily="34" charset="0"/>
                 <a:cs typeface="Calibri" panose="020F0502020204030204" pitchFamily="34" charset="0"/>
               </a:rPr>
@@ -5647,7 +5503,7 @@
               <a:solidFill>
                 <a:srgbClr val="E67E22"/>
               </a:solidFill>
-              <a:latin typeface="DM Sans" pitchFamily="2" charset="0"/>
+              <a:latin typeface="Museo Sans 300" panose="02000000000000000000" pitchFamily="50" charset="0"/>
               <a:ea typeface="Calibri" panose="020F0502020204030204" pitchFamily="34" charset="0"/>
               <a:cs typeface="Calibri" panose="020F0502020204030204" pitchFamily="34" charset="0"/>
             </a:endParaRPr>
@@ -5658,7 +5514,7 @@
                 <a:solidFill>
                   <a:srgbClr val="E67E22"/>
                 </a:solidFill>
-                <a:latin typeface="DM Sans" pitchFamily="2" charset="0"/>
+                <a:latin typeface="Museo Sans 300" panose="02000000000000000000" pitchFamily="50" charset="0"/>
                 <a:ea typeface="Calibri" panose="020F0502020204030204" pitchFamily="34" charset="0"/>
                 <a:cs typeface="Calibri" panose="020F0502020204030204" pitchFamily="34" charset="0"/>
               </a:rPr>
@@ -5669,7 +5525,7 @@
                 <a:solidFill>
                   <a:srgbClr val="E67E22"/>
                 </a:solidFill>
-                <a:latin typeface="DM Sans" pitchFamily="2" charset="0"/>
+                <a:latin typeface="Museo Sans 300" panose="02000000000000000000" pitchFamily="50" charset="0"/>
                 <a:ea typeface="Calibri" panose="020F0502020204030204" pitchFamily="34" charset="0"/>
                 <a:cs typeface="Calibri" panose="020F0502020204030204" pitchFamily="34" charset="0"/>
                 <a:hlinkClick r:id="rId3">
@@ -5686,7 +5542,7 @@
               <a:solidFill>
                 <a:srgbClr val="E67E22"/>
               </a:solidFill>
-              <a:latin typeface="DM Sans" pitchFamily="2" charset="0"/>
+              <a:latin typeface="Museo Sans 300" panose="02000000000000000000" pitchFamily="50" charset="0"/>
               <a:ea typeface="Calibri" panose="020F0502020204030204" pitchFamily="34" charset="0"/>
               <a:cs typeface="Calibri" panose="020F0502020204030204" pitchFamily="34" charset="0"/>
             </a:endParaRPr>
@@ -5721,7 +5577,7 @@
         <p:spPr>
           <a:xfrm>
             <a:off x="621460" y="3525080"/>
-            <a:ext cx="1232552" cy="246221"/>
+            <a:ext cx="1397840" cy="246221"/>
           </a:xfrm>
           <a:prstGeom prst="rect">
             <a:avLst/>
@@ -5739,7 +5595,7 @@
                 <a:solidFill>
                   <a:srgbClr val="002060"/>
                 </a:solidFill>
-                <a:latin typeface="DM Sans" pitchFamily="2" charset="0"/>
+                <a:latin typeface="Museo Sans 500" panose="02000000000000000000" pitchFamily="50" charset="0"/>
                 <a:cs typeface="Times New Roman" panose="02020603050405020304" pitchFamily="18" charset="0"/>
               </a:rPr>
               <a:t>CMG</a:t>
@@ -5749,7 +5605,7 @@
                 <a:solidFill>
                   <a:srgbClr val="8EC5FF"/>
                 </a:solidFill>
-                <a:latin typeface="DM Sans" pitchFamily="2" charset="0"/>
+                <a:latin typeface="Museo Sans 500" panose="02000000000000000000" pitchFamily="50" charset="0"/>
                 <a:ea typeface="Calibri" panose="020F0502020204030204" pitchFamily="34" charset="0"/>
                 <a:cs typeface="Calibri" panose="020F0502020204030204" pitchFamily="34" charset="0"/>
               </a:rPr>
@@ -5760,7 +5616,7 @@
                 <a:solidFill>
                   <a:srgbClr val="002060"/>
                 </a:solidFill>
-                <a:latin typeface="DM Sans" pitchFamily="2" charset="0"/>
+                <a:latin typeface="Museo Sans 500" panose="02000000000000000000" pitchFamily="50" charset="0"/>
                 <a:cs typeface="Times New Roman" panose="02020603050405020304" pitchFamily="18" charset="0"/>
               </a:rPr>
               <a:t>PROMEDIO</a:t>
@@ -5803,7 +5659,7 @@
                 <a:solidFill>
                   <a:srgbClr val="002060"/>
                 </a:solidFill>
-                <a:latin typeface="DM Sans" pitchFamily="2" charset="0"/>
+                <a:latin typeface="Museo Sans 500" panose="02000000000000000000" pitchFamily="50" charset="0"/>
                 <a:cs typeface="Times New Roman" panose="02020603050405020304" pitchFamily="18" charset="0"/>
               </a:rPr>
               <a:t>SPREAD</a:t>
@@ -5813,7 +5669,7 @@
                 <a:solidFill>
                   <a:srgbClr val="8EC5FF"/>
                 </a:solidFill>
-                <a:latin typeface="DM Sans" pitchFamily="2" charset="0"/>
+                <a:latin typeface="Museo Sans 500" panose="02000000000000000000" pitchFamily="50" charset="0"/>
                 <a:ea typeface="Calibri" panose="020F0502020204030204" pitchFamily="34" charset="0"/>
                 <a:cs typeface="Calibri" panose="020F0502020204030204" pitchFamily="34" charset="0"/>
               </a:rPr>
@@ -5824,7 +5680,7 @@
                 <a:solidFill>
                   <a:srgbClr val="002060"/>
                 </a:solidFill>
-                <a:latin typeface="DM Sans" pitchFamily="2" charset="0"/>
+                <a:latin typeface="Museo Sans 500" panose="02000000000000000000" pitchFamily="50" charset="0"/>
                 <a:cs typeface="Times New Roman" panose="02020603050405020304" pitchFamily="18" charset="0"/>
               </a:rPr>
               <a:t>MÁXIMO</a:t>
@@ -5833,7 +5689,7 @@
               <a:solidFill>
                 <a:srgbClr val="002060"/>
               </a:solidFill>
-              <a:latin typeface="DM Sans" pitchFamily="2" charset="0"/>
+              <a:latin typeface="Museo Sans 500" panose="02000000000000000000" pitchFamily="50" charset="0"/>
               <a:cs typeface="Times New Roman" panose="02020603050405020304" pitchFamily="18" charset="0"/>
             </a:endParaRPr>
           </a:p>
@@ -5855,8 +5711,8 @@
         </p:nvSpPr>
         <p:spPr>
           <a:xfrm>
-            <a:off x="5623588" y="3511340"/>
-            <a:ext cx="2183314" cy="246221"/>
+            <a:off x="5623587" y="3511340"/>
+            <a:ext cx="2302423" cy="246221"/>
           </a:xfrm>
           <a:prstGeom prst="rect">
             <a:avLst/>
@@ -5874,7 +5730,7 @@
                 <a:solidFill>
                   <a:srgbClr val="002060"/>
                 </a:solidFill>
-                <a:latin typeface="DM Sans" pitchFamily="2" charset="0"/>
+                <a:latin typeface="Museo Sans 500" panose="02000000000000000000" pitchFamily="50" charset="0"/>
                 <a:cs typeface="Times New Roman" panose="02020603050405020304" pitchFamily="18" charset="0"/>
               </a:rPr>
               <a:t>REDUCCIÓN RENOVABLE TOTAL</a:t>
@@ -5917,7 +5773,7 @@
                 <a:solidFill>
                   <a:srgbClr val="002060"/>
                 </a:solidFill>
-                <a:latin typeface="DM Sans" pitchFamily="2" charset="0"/>
+                <a:latin typeface="Museo Sans 500" panose="02000000000000000000" pitchFamily="50" charset="0"/>
                 <a:cs typeface="Times New Roman" panose="02020603050405020304" pitchFamily="18" charset="0"/>
               </a:rPr>
               <a:t>REDUCCIÓN RENOVABLE MAX.</a:t>
@@ -5985,7 +5841,7 @@
                 <a:solidFill>
                   <a:srgbClr val="002060"/>
                 </a:solidFill>
-                <a:latin typeface="DM Sans" pitchFamily="2" charset="0"/>
+                <a:latin typeface="Museo Sans 500" panose="02000000000000000000" pitchFamily="50" charset="0"/>
                 <a:cs typeface="Times New Roman" panose="02020603050405020304" pitchFamily="18" charset="0"/>
               </a:rPr>
               <a:t>CMg</a:t>
@@ -5995,7 +5851,7 @@
                 <a:solidFill>
                   <a:srgbClr val="002060"/>
                 </a:solidFill>
-                <a:latin typeface="DM Sans" pitchFamily="2" charset="0"/>
+                <a:latin typeface="Museo Sans 500" panose="02000000000000000000" pitchFamily="50" charset="0"/>
                 <a:cs typeface="Times New Roman" panose="02020603050405020304" pitchFamily="18" charset="0"/>
               </a:rPr>
               <a:t> promedio por mes</a:t>
@@ -6004,7 +5860,7 @@
               <a:solidFill>
                 <a:srgbClr val="002060"/>
               </a:solidFill>
-              <a:latin typeface="DM Sans" pitchFamily="2" charset="0"/>
+              <a:latin typeface="Museo Sans 500" panose="02000000000000000000" pitchFamily="50" charset="0"/>
               <a:cs typeface="Times New Roman" panose="02020603050405020304" pitchFamily="18" charset="0"/>
             </a:endParaRPr>
           </a:p>
@@ -6046,7 +5902,7 @@
                 <a:solidFill>
                   <a:srgbClr val="002060"/>
                 </a:solidFill>
-                <a:latin typeface="DM Sans" pitchFamily="2" charset="0"/>
+                <a:latin typeface="Museo Sans 500" panose="02000000000000000000" pitchFamily="50" charset="0"/>
                 <a:cs typeface="Times New Roman" panose="02020603050405020304" pitchFamily="18" charset="0"/>
               </a:rPr>
               <a:t>$/kWh</a:t>
@@ -6055,7 +5911,7 @@
               <a:solidFill>
                 <a:srgbClr val="002060"/>
               </a:solidFill>
-              <a:latin typeface="DM Sans" pitchFamily="2" charset="0"/>
+              <a:latin typeface="Museo Sans 500" panose="02000000000000000000" pitchFamily="50" charset="0"/>
               <a:cs typeface="Times New Roman" panose="02020603050405020304" pitchFamily="18" charset="0"/>
             </a:endParaRPr>
           </a:p>
@@ -6097,7 +5953,7 @@
                 <a:solidFill>
                   <a:srgbClr val="002060"/>
                 </a:solidFill>
-                <a:latin typeface="DM Sans" pitchFamily="2" charset="0"/>
+                <a:latin typeface="Museo Sans 500" panose="02000000000000000000" pitchFamily="50" charset="0"/>
                 <a:cs typeface="Times New Roman" panose="02020603050405020304" pitchFamily="18" charset="0"/>
               </a:rPr>
               <a:t>Mes</a:t>
@@ -6106,7 +5962,58 @@
               <a:solidFill>
                 <a:srgbClr val="002060"/>
               </a:solidFill>
-              <a:latin typeface="DM Sans" pitchFamily="2" charset="0"/>
+              <a:latin typeface="Museo Sans 500" panose="02000000000000000000" pitchFamily="50" charset="0"/>
+              <a:cs typeface="Times New Roman" panose="02020603050405020304" pitchFamily="18" charset="0"/>
+            </a:endParaRPr>
+          </a:p>
+        </p:txBody>
+      </p:sp>
+      <p:sp>
+        <p:nvSpPr>
+          <p:cNvPr id="14" name="titulo_ubicacion_barras">
+            <a:extLst>
+              <a:ext uri="{FF2B5EF4-FFF2-40B4-BE49-F238E27FC236}">
+                <a16:creationId xmlns:a16="http://schemas.microsoft.com/office/drawing/2014/main" id="{97382C54-08E1-03B3-5C0F-3054406FE845}"/>
+              </a:ext>
+            </a:extLst>
+          </p:cNvPr>
+          <p:cNvSpPr txBox="1">
+            <a:spLocks/>
+          </p:cNvSpPr>
+          <p:nvPr/>
+        </p:nvSpPr>
+        <p:spPr>
+          <a:xfrm rot="5400000">
+            <a:off x="8800466" y="11314402"/>
+            <a:ext cx="2266947" cy="276999"/>
+          </a:xfrm>
+          <a:prstGeom prst="rect">
+            <a:avLst/>
+          </a:prstGeom>
+          <a:noFill/>
+        </p:spPr>
+        <p:txBody>
+          <a:bodyPr wrap="square" rtlCol="0">
+            <a:spAutoFit/>
+          </a:bodyPr>
+          <a:lstStyle/>
+          <a:p>
+            <a:pPr algn="ctr"/>
+            <a:r>
+              <a:rPr lang="es-ES" sz="1200" b="1" kern="100" dirty="0">
+                <a:solidFill>
+                  <a:srgbClr val="002060"/>
+                </a:solidFill>
+                <a:latin typeface="Museo Sans 500" panose="02000000000000000000" pitchFamily="50" charset="0"/>
+                <a:cs typeface="Times New Roman" panose="02020603050405020304" pitchFamily="18" charset="0"/>
+              </a:rPr>
+              <a:t>Ubicación de las barras</a:t>
+            </a:r>
+            <a:endParaRPr lang="es-CL" sz="1200" b="1" kern="100" dirty="0">
+              <a:solidFill>
+                <a:srgbClr val="002060"/>
+              </a:solidFill>
+              <a:latin typeface="Museo Sans 500" panose="02000000000000000000" pitchFamily="50" charset="0"/>
               <a:cs typeface="Times New Roman" panose="02020603050405020304" pitchFamily="18" charset="0"/>
             </a:endParaRPr>
           </a:p>
@@ -6233,7 +6140,7 @@
                 <a:solidFill>
                   <a:srgbClr val="002060"/>
                 </a:solidFill>
-                <a:latin typeface="DM Sans" pitchFamily="2" charset="0"/>
+                <a:latin typeface="gobCL" pitchFamily="50" charset="0"/>
                 <a:cs typeface="Times New Roman" panose="02020603050405020304" pitchFamily="18" charset="0"/>
               </a:rPr>
               <a:t>SEÑALES DE MERCADO PARA EL INVERSIONISTA</a:t>
@@ -6406,7 +6313,7 @@
                 <a:solidFill>
                   <a:srgbClr val="2C2E38"/>
                 </a:solidFill>
-                <a:latin typeface="DM Sans" pitchFamily="2" charset="0"/>
+                <a:latin typeface="Museo Sans 300" panose="02000000000000000000" pitchFamily="50" charset="0"/>
                 <a:ea typeface="Calibri" panose="020F0502020204030204" pitchFamily="34" charset="0"/>
                 <a:cs typeface="Calibri" panose="020F0502020204030204" pitchFamily="34" charset="0"/>
               </a:rPr>
@@ -6417,7 +6324,7 @@
                 <a:solidFill>
                   <a:srgbClr val="2C2E38"/>
                 </a:solidFill>
-                <a:latin typeface="DM Sans" pitchFamily="2" charset="0"/>
+                <a:latin typeface="Museo Sans 300" panose="02000000000000000000" pitchFamily="50" charset="0"/>
                 <a:ea typeface="Calibri" panose="020F0502020204030204" pitchFamily="34" charset="0"/>
                 <a:cs typeface="Calibri" panose="020F0502020204030204" pitchFamily="34" charset="0"/>
               </a:rPr>
@@ -6428,7 +6335,7 @@
                 <a:solidFill>
                   <a:srgbClr val="2C2E38"/>
                 </a:solidFill>
-                <a:latin typeface="DM Sans" pitchFamily="2" charset="0"/>
+                <a:latin typeface="Museo Sans 300" panose="02000000000000000000" pitchFamily="50" charset="0"/>
                 <a:ea typeface="Calibri" panose="020F0502020204030204" pitchFamily="34" charset="0"/>
                 <a:cs typeface="Calibri" panose="020F0502020204030204" pitchFamily="34" charset="0"/>
               </a:rPr>
@@ -6445,7 +6352,7 @@
               <a:solidFill>
                 <a:srgbClr val="2C2E38"/>
               </a:solidFill>
-              <a:latin typeface="DM Sans" pitchFamily="2" charset="0"/>
+              <a:latin typeface="Museo Sans 300" panose="02000000000000000000" pitchFamily="50" charset="0"/>
               <a:ea typeface="Calibri" panose="020F0502020204030204" pitchFamily="34" charset="0"/>
               <a:cs typeface="Calibri" panose="020F0502020204030204" pitchFamily="34" charset="0"/>
             </a:endParaRPr>
@@ -6461,7 +6368,7 @@
                 <a:solidFill>
                   <a:srgbClr val="2C2E38"/>
                 </a:solidFill>
-                <a:latin typeface="DM Sans" pitchFamily="2" charset="0"/>
+                <a:latin typeface="Museo Sans 300" panose="02000000000000000000" pitchFamily="50" charset="0"/>
                 <a:ea typeface="Calibri" panose="020F0502020204030204" pitchFamily="34" charset="0"/>
                 <a:cs typeface="Calibri" panose="020F0502020204030204" pitchFamily="34" charset="0"/>
               </a:rPr>
@@ -6472,7 +6379,7 @@
                 <a:solidFill>
                   <a:srgbClr val="2C2E38"/>
                 </a:solidFill>
-                <a:latin typeface="DM Sans" pitchFamily="2" charset="0"/>
+                <a:latin typeface="Museo Sans 300" panose="02000000000000000000" pitchFamily="50" charset="0"/>
                 <a:ea typeface="Calibri" panose="020F0502020204030204" pitchFamily="34" charset="0"/>
                 <a:cs typeface="Calibri" panose="020F0502020204030204" pitchFamily="34" charset="0"/>
               </a:rPr>
@@ -6483,7 +6390,7 @@
                 <a:solidFill>
                   <a:srgbClr val="2C2E38"/>
                 </a:solidFill>
-                <a:latin typeface="DM Sans" pitchFamily="2" charset="0"/>
+                <a:latin typeface="Museo Sans 300" panose="02000000000000000000" pitchFamily="50" charset="0"/>
                 <a:ea typeface="Calibri" panose="020F0502020204030204" pitchFamily="34" charset="0"/>
                 <a:cs typeface="Calibri" panose="020F0502020204030204" pitchFamily="34" charset="0"/>
               </a:rPr>
@@ -6672,55 +6579,33 @@
                 <a:solidFill>
                   <a:srgbClr val="2C2E38"/>
                 </a:solidFill>
-                <a:latin typeface="DM Sans" pitchFamily="2" charset="0"/>
+                <a:latin typeface="Museo Sans 300" panose="02000000000000000000" pitchFamily="50" charset="0"/>
                 <a:ea typeface="Calibri" panose="020F0502020204030204" pitchFamily="34" charset="0"/>
                 <a:cs typeface="Calibri" panose="020F0502020204030204" pitchFamily="34" charset="0"/>
               </a:rPr>
-              <a:t>La inyección de energía por parte de sistemas BESS muestra un crecimiento sostenido a lo largo del período, llegando a un acumulado de </a:t>
-            </a:r>
-            <a:r>
-              <a:rPr lang="es-CL" sz="1200" dirty="0">
+              <a:t>La inyección de energía por parte de sistemas BESS muestra un crecimiento sostenido a lo largo del período, llegando a un acumulado de 275.124 </a:t>
+            </a:r>
+            <a:r>
+              <a:rPr lang="es-CL" sz="1200" dirty="0" err="1">
                 <a:solidFill>
                   <a:srgbClr val="2C2E38"/>
                 </a:solidFill>
-                <a:latin typeface="DM Mono" panose="020B0509040201040103" pitchFamily="49" charset="0"/>
+                <a:latin typeface="Museo Sans 300" panose="02000000000000000000" pitchFamily="50" charset="0"/>
                 <a:ea typeface="Calibri" panose="020F0502020204030204" pitchFamily="34" charset="0"/>
                 <a:cs typeface="Calibri" panose="020F0502020204030204" pitchFamily="34" charset="0"/>
               </a:rPr>
-              <a:t>275.124 </a:t>
-            </a:r>
-            <a:r>
-              <a:rPr lang="es-CL" sz="1200" dirty="0" err="1">
+              <a:t>MWh</a:t>
+            </a:r>
+            <a:r>
+              <a:rPr lang="es-CL" sz="1200" dirty="0">
                 <a:solidFill>
                   <a:srgbClr val="2C2E38"/>
                 </a:solidFill>
-                <a:latin typeface="DM Mono" panose="020B0509040201040103" pitchFamily="49" charset="0"/>
+                <a:latin typeface="Museo Sans 300" panose="02000000000000000000" pitchFamily="50" charset="0"/>
                 <a:ea typeface="Calibri" panose="020F0502020204030204" pitchFamily="34" charset="0"/>
                 <a:cs typeface="Calibri" panose="020F0502020204030204" pitchFamily="34" charset="0"/>
               </a:rPr>
-              <a:t>MWh</a:t>
-            </a:r>
-            <a:r>
-              <a:rPr lang="es-CL" sz="1200" dirty="0">
-                <a:solidFill>
-                  <a:srgbClr val="2C2E38"/>
-                </a:solidFill>
-                <a:latin typeface="DM Mono" panose="020B0509040201040103" pitchFamily="49" charset="0"/>
-                <a:ea typeface="Calibri" panose="020F0502020204030204" pitchFamily="34" charset="0"/>
-                <a:cs typeface="Calibri" panose="020F0502020204030204" pitchFamily="34" charset="0"/>
-              </a:rPr>
-              <a:t> </a:t>
-            </a:r>
-            <a:r>
-              <a:rPr lang="es-CL" sz="1200" dirty="0">
-                <a:solidFill>
-                  <a:srgbClr val="2C2E38"/>
-                </a:solidFill>
-                <a:latin typeface="DM Sans" pitchFamily="2" charset="0"/>
-                <a:ea typeface="Calibri" panose="020F0502020204030204" pitchFamily="34" charset="0"/>
-                <a:cs typeface="Calibri" panose="020F0502020204030204" pitchFamily="34" charset="0"/>
-              </a:rPr>
-              <a:t>al fin del cuatro trimestre.</a:t>
+              <a:t> al fin del cuatro trimestre.</a:t>
             </a:r>
           </a:p>
           <a:p>
@@ -6733,7 +6618,7 @@
               <a:solidFill>
                 <a:srgbClr val="2C2E38"/>
               </a:solidFill>
-              <a:latin typeface="DM Sans" pitchFamily="2" charset="0"/>
+              <a:latin typeface="Museo Sans 300" panose="02000000000000000000" pitchFamily="50" charset="0"/>
               <a:ea typeface="Calibri" panose="020F0502020204030204" pitchFamily="34" charset="0"/>
               <a:cs typeface="Calibri" panose="020F0502020204030204" pitchFamily="34" charset="0"/>
             </a:endParaRPr>
@@ -6749,33 +6634,11 @@
                 <a:solidFill>
                   <a:srgbClr val="2C2E38"/>
                 </a:solidFill>
-                <a:latin typeface="DM Sans" pitchFamily="2" charset="0"/>
+                <a:latin typeface="Museo Sans 300" panose="02000000000000000000" pitchFamily="50" charset="0"/>
                 <a:ea typeface="Calibri" panose="020F0502020204030204" pitchFamily="34" charset="0"/>
                 <a:cs typeface="Calibri" panose="020F0502020204030204" pitchFamily="34" charset="0"/>
               </a:rPr>
-              <a:t> Al comparar con </a:t>
-            </a:r>
-            <a:r>
-              <a:rPr lang="es-CL" sz="1200" dirty="0">
-                <a:solidFill>
-                  <a:srgbClr val="2C2E38"/>
-                </a:solidFill>
-                <a:latin typeface="DM Mono" panose="020B0509040201040103" pitchFamily="49" charset="0"/>
-                <a:ea typeface="Calibri" panose="020F0502020204030204" pitchFamily="34" charset="0"/>
-                <a:cs typeface="Calibri" panose="020F0502020204030204" pitchFamily="34" charset="0"/>
-              </a:rPr>
-              <a:t>2024</a:t>
-            </a:r>
-            <a:r>
-              <a:rPr lang="es-CL" sz="1200" dirty="0">
-                <a:solidFill>
-                  <a:srgbClr val="2C2E38"/>
-                </a:solidFill>
-                <a:latin typeface="DM Sans" pitchFamily="2" charset="0"/>
-                <a:ea typeface="Calibri" panose="020F0502020204030204" pitchFamily="34" charset="0"/>
-                <a:cs typeface="Calibri" panose="020F0502020204030204" pitchFamily="34" charset="0"/>
-              </a:rPr>
-              <a:t>, la expansión es evidente en todos los trimestres. Esta trayectoria es consistente con la señal de spread que entrega el mercado: a mayor diferencial de precio día/noche, mayor el incentivo para cargar en horas solares y descargar en horarios no solares.</a:t>
+              <a:t> Al comparar con 2024, la expansión es evidente en todos los trimestres. Esta trayectoria es consistente con la señal de spread que entrega el mercado: a mayor diferencial de precio día/noche, mayor el incentivo para cargar en horas solares y descargar en horarios no solares.</a:t>
             </a:r>
           </a:p>
         </p:txBody>
@@ -6830,61 +6693,17 @@
                 <a:solidFill>
                   <a:srgbClr val="2C2E38"/>
                 </a:solidFill>
-                <a:latin typeface="DM Sans" pitchFamily="2" charset="0"/>
+                <a:latin typeface="Museo Sans 300" panose="02000000000000000000" pitchFamily="50" charset="0"/>
                 <a:ea typeface="Calibri" panose="020F0502020204030204" pitchFamily="34" charset="0"/>
                 <a:cs typeface="Calibri" panose="020F0502020204030204" pitchFamily="34" charset="0"/>
               </a:rPr>
-              <a:t>Los 3 primeros trimestres del </a:t>
-            </a:r>
-            <a:r>
-              <a:rPr lang="es-CL" sz="1200" dirty="0">
-                <a:solidFill>
-                  <a:srgbClr val="2C2E38"/>
-                </a:solidFill>
-                <a:latin typeface="DM Mono" panose="020B0509040201040103" pitchFamily="49" charset="0"/>
-                <a:ea typeface="Calibri" panose="020F0502020204030204" pitchFamily="34" charset="0"/>
-                <a:cs typeface="Calibri" panose="020F0502020204030204" pitchFamily="34" charset="0"/>
-              </a:rPr>
-              <a:t>2025</a:t>
-            </a:r>
-            <a:r>
-              <a:rPr lang="es-CL" sz="1200" dirty="0">
-                <a:solidFill>
-                  <a:srgbClr val="2C2E38"/>
-                </a:solidFill>
-                <a:latin typeface="DM Sans" pitchFamily="2" charset="0"/>
-                <a:ea typeface="Calibri" panose="020F0502020204030204" pitchFamily="34" charset="0"/>
-                <a:cs typeface="Calibri" panose="020F0502020204030204" pitchFamily="34" charset="0"/>
-              </a:rPr>
-              <a:t> superaron a sus homólogos del </a:t>
-            </a:r>
-            <a:r>
-              <a:rPr lang="es-CL" sz="1200" dirty="0">
-                <a:solidFill>
-                  <a:srgbClr val="2C2E38"/>
-                </a:solidFill>
-                <a:latin typeface="DM Mono" panose="020B0509040201040103" pitchFamily="49" charset="0"/>
-                <a:ea typeface="Calibri" panose="020F0502020204030204" pitchFamily="34" charset="0"/>
-                <a:cs typeface="Calibri" panose="020F0502020204030204" pitchFamily="34" charset="0"/>
-              </a:rPr>
-              <a:t>2024</a:t>
-            </a:r>
-            <a:r>
-              <a:rPr lang="es-CL" sz="1200" dirty="0">
-                <a:solidFill>
-                  <a:srgbClr val="2C2E38"/>
-                </a:solidFill>
-                <a:latin typeface="DM Sans" pitchFamily="2" charset="0"/>
-                <a:ea typeface="Calibri" panose="020F0502020204030204" pitchFamily="34" charset="0"/>
-                <a:cs typeface="Calibri" panose="020F0502020204030204" pitchFamily="34" charset="0"/>
-              </a:rPr>
-              <a:t> en cuanto a la energía renovable reducida. No obstante, al comparar los últimos trimestres de ambos años, se observa una disminución de estas reducciones, lo que se condice con el acelerado aumento de la participación BESS en el sistema. Sin embargo, aún falta tiempo para poder concluir de manera certera que esta tecnología esté generando la tendencia a la baja. </a:t>
+              <a:t>Los 3 primeros trimestres del 2025 superaron a sus homólogos del 2024 en cuanto a la energía renovable reducida. No obstante, al comparar los últimos trimestres de ambos años, se observa una disminución de estas reducciones, lo que se condice con el acelerado aumento de la participación BESS en el sistema. Sin embargo, aún falta tiempo para poder concluir de manera certera que esta tecnología esté generando la tendencia a la baja. </a:t>
             </a:r>
             <a:endParaRPr lang="es-CL" sz="1200" dirty="0">
               <a:solidFill>
                 <a:srgbClr val="2C2E38"/>
               </a:solidFill>
-              <a:latin typeface="DM Sans" pitchFamily="2" charset="0"/>
+              <a:latin typeface="Museo Sans 300" panose="02000000000000000000" pitchFamily="50" charset="0"/>
             </a:endParaRPr>
           </a:p>
         </p:txBody>
@@ -7343,7 +7162,7 @@
                 <a:solidFill>
                   <a:schemeClr val="bg1"/>
                 </a:solidFill>
-                <a:latin typeface="DM Sans" pitchFamily="2" charset="0"/>
+                <a:latin typeface="gobCL" pitchFamily="50" charset="0"/>
                 <a:ea typeface="Aptos" panose="020B0004020202020204" pitchFamily="34" charset="0"/>
                 <a:cs typeface="Times New Roman" panose="02020603050405020304" pitchFamily="18" charset="0"/>
               </a:rPr>
@@ -7353,7 +7172,7 @@
               <a:solidFill>
                 <a:schemeClr val="bg1"/>
               </a:solidFill>
-              <a:latin typeface="DM Sans" pitchFamily="2" charset="0"/>
+              <a:latin typeface="gobCL" pitchFamily="50" charset="0"/>
               <a:ea typeface="Aptos" panose="020B0004020202020204" pitchFamily="34" charset="0"/>
               <a:cs typeface="Times New Roman" panose="02020603050405020304" pitchFamily="18" charset="0"/>
             </a:endParaRPr>
@@ -7401,20 +7220,20 @@
                 <a:solidFill>
                   <a:srgbClr val="6FA3CC"/>
                 </a:solidFill>
-                <a:latin typeface="DM Sans" pitchFamily="2" charset="0"/>
+                <a:latin typeface="gobCL" pitchFamily="50" charset="0"/>
                 <a:cs typeface="Times New Roman" panose="02020603050405020304" pitchFamily="18" charset="0"/>
               </a:rPr>
-              <a:t>Periodo de estudio: </a:t>
+              <a:t>Mes de estudio: </a:t>
             </a:r>
             <a:r>
               <a:rPr lang="es-CL" sz="1600" b="1" kern="100" dirty="0">
                 <a:solidFill>
                   <a:srgbClr val="6FA3CC"/>
                 </a:solidFill>
-                <a:latin typeface="DM Mono" panose="020B0509040201040103" pitchFamily="49" charset="0"/>
+                <a:latin typeface="Museo Sans 300" panose="02000000000000000000" pitchFamily="50" charset="0"/>
                 <a:cs typeface="Times New Roman" panose="02020603050405020304" pitchFamily="18" charset="0"/>
               </a:rPr>
-              <a:t>2025-02 → 2026-01</a:t>
+              <a:t>2026-01</a:t>
             </a:r>
           </a:p>
         </p:txBody>
@@ -7578,7 +7397,7 @@
                 <a:solidFill>
                   <a:srgbClr val="002060"/>
                 </a:solidFill>
-                <a:latin typeface="DM Sans" pitchFamily="2" charset="0"/>
+                <a:latin typeface="Museo Sans 300" panose="02000000000000000000" pitchFamily="50" charset="0"/>
                 <a:cs typeface="Times New Roman" panose="02020603050405020304" pitchFamily="18" charset="0"/>
               </a:rPr>
               <a:t>CMg</a:t>
@@ -7588,7 +7407,7 @@
                 <a:solidFill>
                   <a:srgbClr val="002060"/>
                 </a:solidFill>
-                <a:latin typeface="DM Sans" pitchFamily="2" charset="0"/>
+                <a:latin typeface="Museo Sans 300" panose="02000000000000000000" pitchFamily="50" charset="0"/>
                 <a:cs typeface="Times New Roman" panose="02020603050405020304" pitchFamily="18" charset="0"/>
               </a:rPr>
               <a:t> promedio: horas solares vs no solares</a:t>
@@ -7597,7 +7416,7 @@
               <a:solidFill>
                 <a:srgbClr val="002060"/>
               </a:solidFill>
-              <a:latin typeface="DM Sans" pitchFamily="2" charset="0"/>
+              <a:latin typeface="Museo Sans 300" panose="02000000000000000000" pitchFamily="50" charset="0"/>
               <a:cs typeface="Times New Roman" panose="02020603050405020304" pitchFamily="18" charset="0"/>
             </a:endParaRPr>
           </a:p>
@@ -7639,7 +7458,7 @@
                 <a:solidFill>
                   <a:srgbClr val="002060"/>
                 </a:solidFill>
-                <a:latin typeface="DM Sans" pitchFamily="2" charset="0"/>
+                <a:latin typeface="Museo Sans 500" panose="02000000000000000000" pitchFamily="50" charset="0"/>
                 <a:cs typeface="Times New Roman" panose="02020603050405020304" pitchFamily="18" charset="0"/>
               </a:rPr>
               <a:t>Evolución trimestral de inyección BESS</a:t>
@@ -7648,7 +7467,7 @@
               <a:solidFill>
                 <a:srgbClr val="002060"/>
               </a:solidFill>
-              <a:latin typeface="DM Sans" pitchFamily="2" charset="0"/>
+              <a:latin typeface="Museo Sans 500" panose="02000000000000000000" pitchFamily="50" charset="0"/>
               <a:cs typeface="Times New Roman" panose="02020603050405020304" pitchFamily="18" charset="0"/>
             </a:endParaRPr>
           </a:p>
@@ -7690,7 +7509,7 @@
                 <a:solidFill>
                   <a:srgbClr val="002060"/>
                 </a:solidFill>
-                <a:latin typeface="DM Sans" pitchFamily="2" charset="0"/>
+                <a:latin typeface="Museo Sans 500" panose="02000000000000000000" pitchFamily="50" charset="0"/>
                 <a:cs typeface="Times New Roman" panose="02020603050405020304" pitchFamily="18" charset="0"/>
               </a:rPr>
               <a:t>MWh</a:t>
@@ -7699,7 +7518,7 @@
               <a:solidFill>
                 <a:srgbClr val="002060"/>
               </a:solidFill>
-              <a:latin typeface="DM Sans" pitchFamily="2" charset="0"/>
+              <a:latin typeface="Museo Sans 500" panose="02000000000000000000" pitchFamily="50" charset="0"/>
               <a:cs typeface="Times New Roman" panose="02020603050405020304" pitchFamily="18" charset="0"/>
             </a:endParaRPr>
           </a:p>
@@ -7741,7 +7560,7 @@
                 <a:solidFill>
                   <a:srgbClr val="002060"/>
                 </a:solidFill>
-                <a:latin typeface="DM Sans" pitchFamily="2" charset="0"/>
+                <a:latin typeface="Museo Sans 500" panose="02000000000000000000" pitchFamily="50" charset="0"/>
                 <a:cs typeface="Times New Roman" panose="02020603050405020304" pitchFamily="18" charset="0"/>
               </a:rPr>
               <a:t>MWh</a:t>
@@ -7750,7 +7569,7 @@
               <a:solidFill>
                 <a:srgbClr val="002060"/>
               </a:solidFill>
-              <a:latin typeface="DM Sans" pitchFamily="2" charset="0"/>
+              <a:latin typeface="Museo Sans 500" panose="02000000000000000000" pitchFamily="50" charset="0"/>
               <a:cs typeface="Times New Roman" panose="02020603050405020304" pitchFamily="18" charset="0"/>
             </a:endParaRPr>
           </a:p>
@@ -7792,7 +7611,7 @@
                 <a:solidFill>
                   <a:srgbClr val="002060"/>
                 </a:solidFill>
-                <a:latin typeface="DM Sans" pitchFamily="2" charset="0"/>
+                <a:latin typeface="Museo Sans 500" panose="02000000000000000000" pitchFamily="50" charset="0"/>
                 <a:cs typeface="Times New Roman" panose="02020603050405020304" pitchFamily="18" charset="0"/>
               </a:rPr>
               <a:t>Reducciones de energía renovable</a:t>
@@ -7801,7 +7620,7 @@
               <a:solidFill>
                 <a:srgbClr val="002060"/>
               </a:solidFill>
-              <a:latin typeface="DM Sans" pitchFamily="2" charset="0"/>
+              <a:latin typeface="Museo Sans 500" panose="02000000000000000000" pitchFamily="50" charset="0"/>
               <a:cs typeface="Times New Roman" panose="02020603050405020304" pitchFamily="18" charset="0"/>
             </a:endParaRPr>
           </a:p>
@@ -7874,7 +7693,7 @@
         </p:nvSpPr>
         <p:spPr>
           <a:xfrm>
-            <a:off x="2742983" y="9585137"/>
+            <a:off x="2711068" y="9438023"/>
             <a:ext cx="928814" cy="276999"/>
           </a:xfrm>
           <a:prstGeom prst="rect">
@@ -7894,7 +7713,7 @@
                 <a:solidFill>
                   <a:srgbClr val="002060"/>
                 </a:solidFill>
-                <a:latin typeface="DM Sans" pitchFamily="2" charset="0"/>
+                <a:latin typeface="Museo Sans 500" panose="02000000000000000000" pitchFamily="50" charset="0"/>
                 <a:cs typeface="Times New Roman" panose="02020603050405020304" pitchFamily="18" charset="0"/>
               </a:rPr>
               <a:t>Trimestre</a:t>
@@ -7903,7 +7722,7 @@
               <a:solidFill>
                 <a:srgbClr val="002060"/>
               </a:solidFill>
-              <a:latin typeface="DM Sans" pitchFamily="2" charset="0"/>
+              <a:latin typeface="Museo Sans 500" panose="02000000000000000000" pitchFamily="50" charset="0"/>
               <a:cs typeface="Times New Roman" panose="02020603050405020304" pitchFamily="18" charset="0"/>
             </a:endParaRPr>
           </a:p>
@@ -7925,7 +7744,7 @@
         </p:nvSpPr>
         <p:spPr>
           <a:xfrm>
-            <a:off x="2742983" y="13507701"/>
+            <a:off x="2711068" y="13360587"/>
             <a:ext cx="928814" cy="276999"/>
           </a:xfrm>
           <a:prstGeom prst="rect">
@@ -7945,7 +7764,7 @@
                 <a:solidFill>
                   <a:srgbClr val="002060"/>
                 </a:solidFill>
-                <a:latin typeface="DM Sans" pitchFamily="2" charset="0"/>
+                <a:latin typeface="Museo Sans 500" panose="02000000000000000000" pitchFamily="50" charset="0"/>
                 <a:cs typeface="Times New Roman" panose="02020603050405020304" pitchFamily="18" charset="0"/>
               </a:rPr>
               <a:t>Trimestre</a:t>
@@ -7954,7 +7773,7 @@
               <a:solidFill>
                 <a:srgbClr val="002060"/>
               </a:solidFill>
-              <a:latin typeface="DM Sans" pitchFamily="2" charset="0"/>
+              <a:latin typeface="Museo Sans 500" panose="02000000000000000000" pitchFamily="50" charset="0"/>
               <a:cs typeface="Times New Roman" panose="02020603050405020304" pitchFamily="18" charset="0"/>
             </a:endParaRPr>
           </a:p>
@@ -8215,7 +8034,7 @@
                 <a:solidFill>
                   <a:srgbClr val="002060"/>
                 </a:solidFill>
-                <a:latin typeface="DM Sans" pitchFamily="2" charset="0"/>
+                <a:latin typeface="gobCL" pitchFamily="50" charset="0"/>
                 <a:cs typeface="Times New Roman" panose="02020603050405020304" pitchFamily="18" charset="0"/>
               </a:rPr>
               <a:t>PERFIL DE GENERACIÓN</a:t>
@@ -8240,7 +8059,7 @@
         <p:spPr>
           <a:xfrm>
             <a:off x="541157" y="1593517"/>
-            <a:ext cx="9231737" cy="2747996"/>
+            <a:ext cx="9231737" cy="2470997"/>
           </a:xfrm>
           <a:prstGeom prst="rect">
             <a:avLst/>
@@ -8275,77 +8094,11 @@
                 <a:solidFill>
                   <a:srgbClr val="2C2E38"/>
                 </a:solidFill>
-                <a:latin typeface="DM Sans" pitchFamily="2" charset="0"/>
+                <a:latin typeface="Museo Sans 300" panose="02000000000000000000" pitchFamily="50" charset="0"/>
                 <a:ea typeface="Calibri" panose="020F0502020204030204" pitchFamily="34" charset="0"/>
                 <a:cs typeface="Calibri" panose="020F0502020204030204" pitchFamily="34" charset="0"/>
               </a:rPr>
-              <a:t>La presente sección profundiza en el análisis de los vertimientos de energía renovable y el perfil de generación registrados durante 2025. Para dimensionar la evolución del fenómeno, se presentan dos perfiles diarios típicos de generación correspondientes a fechas de referencia distintas dentro del período —2025-08-11 y 2022-02-24— lo que permite observar cómo la participación de cada tecnología en la curva de carga varía según la estación y las condiciones del sistema. La comparación entre ambos perfiles ilustra el rol creciente del almacenamiento BESS en la gestión de la rampa vespertina, así como la persistencia de la generación solar como principal fuente de excedentes en horas centrales del día.</a:t>
-            </a:r>
-            <a:r>
-              <a:rPr lang="es-CL" sz="1200" dirty="0">
-                <a:solidFill>
-                  <a:srgbClr val="2C2E38"/>
-                </a:solidFill>
-                <a:latin typeface="DM Mono" panose="020B0509040201040103" pitchFamily="49" charset="0"/>
-                <a:ea typeface="Calibri" panose="020F0502020204030204" pitchFamily="34" charset="0"/>
-                <a:cs typeface="Calibri" panose="020F0502020204030204" pitchFamily="34" charset="0"/>
-              </a:rPr>
-              <a:t/>
-            </a:r>
-            <a:r>
-              <a:rPr lang="es-CL" sz="1200" dirty="0">
-                <a:solidFill>
-                  <a:srgbClr val="2C2E38"/>
-                </a:solidFill>
-                <a:latin typeface="DM Sans" pitchFamily="2" charset="0"/>
-                <a:ea typeface="Calibri" panose="020F0502020204030204" pitchFamily="34" charset="0"/>
-                <a:cs typeface="Calibri" panose="020F0502020204030204" pitchFamily="34" charset="0"/>
-              </a:rPr>
-              <a:t/>
-            </a:r>
-            <a:r>
-              <a:rPr lang="es-CL" sz="1200" dirty="0">
-                <a:solidFill>
-                  <a:srgbClr val="2C2E38"/>
-                </a:solidFill>
-                <a:latin typeface="DM Mono" panose="020B0509040201040103" pitchFamily="49" charset="0"/>
-                <a:ea typeface="Calibri" panose="020F0502020204030204" pitchFamily="34" charset="0"/>
-                <a:cs typeface="Calibri" panose="020F0502020204030204" pitchFamily="34" charset="0"/>
-              </a:rPr>
-              <a:t/>
-            </a:r>
-            <a:r>
-              <a:rPr lang="es-CL" sz="1200" dirty="0">
-                <a:solidFill>
-                  <a:srgbClr val="2C2E38"/>
-                </a:solidFill>
-                <a:latin typeface="DM Sans" pitchFamily="2" charset="0"/>
-                <a:ea typeface="Calibri" panose="020F0502020204030204" pitchFamily="34" charset="0"/>
-                <a:cs typeface="Calibri" panose="020F0502020204030204" pitchFamily="34" charset="0"/>
-              </a:rPr>
-              <a:t/>
-            </a:r>
-            <a:r>
-              <a:rPr lang="es-CL" sz="1200" dirty="0">
-                <a:solidFill>
-                  <a:srgbClr val="2C2E38"/>
-                </a:solidFill>
-                <a:latin typeface="DM Mono" panose="020B0509040201040103" pitchFamily="49" charset="0"/>
-                <a:ea typeface="Calibri" panose="020F0502020204030204" pitchFamily="34" charset="0"/>
-                <a:cs typeface="Calibri" panose="020F0502020204030204" pitchFamily="34" charset="0"/>
-              </a:rPr>
-              <a:t/>
-            </a:r>
-            <a:r>
-              <a:rPr lang="es-CL" sz="1200" dirty="0">
-                <a:solidFill>
-                  <a:srgbClr val="2C2E38"/>
-                </a:solidFill>
-                <a:latin typeface="DM Sans" pitchFamily="2" charset="0"/>
-                <a:ea typeface="Calibri" panose="020F0502020204030204" pitchFamily="34" charset="0"/>
-                <a:cs typeface="Calibri" panose="020F0502020204030204" pitchFamily="34" charset="0"/>
-              </a:rPr>
-              <a:t/>
+              <a:t>La presente sección profundiza en el análisis de los vertimientos de energía renovable y el perfil de generación registrados durante 2025. Para dimensionar la evolución del fenómeno, se presentan dos perfiles diarios típicos de generación correspondientes a fechas de referencia distintas dentro del período —2026-01-12 y 2022-01-17— lo que permite observar cómo la participación de cada tecnología en la curva de carga varía según la estación y las condiciones del sistema. La comparación entre ambos perfiles ilustra el rol creciente del almacenamiento BESS en la gestión de la rampa vespertina, así como la persistencia de la generación solar como principal fuente de excedentes en horas centrales del día.</a:t>
             </a:r>
           </a:p>
           <a:p>
@@ -8792,7 +8545,7 @@
                 <a:solidFill>
                   <a:schemeClr val="bg1"/>
                 </a:solidFill>
-                <a:latin typeface="DM Sans" pitchFamily="2" charset="0"/>
+                <a:latin typeface="gobCL" pitchFamily="50" charset="0"/>
                 <a:ea typeface="Aptos" panose="020B0004020202020204" pitchFamily="34" charset="0"/>
                 <a:cs typeface="Times New Roman" panose="02020603050405020304" pitchFamily="18" charset="0"/>
               </a:rPr>
@@ -8802,7 +8555,7 @@
               <a:solidFill>
                 <a:schemeClr val="bg1"/>
               </a:solidFill>
-              <a:latin typeface="DM Sans" pitchFamily="2" charset="0"/>
+              <a:latin typeface="gobCL" pitchFamily="50" charset="0"/>
               <a:ea typeface="Aptos" panose="020B0004020202020204" pitchFamily="34" charset="0"/>
               <a:cs typeface="Times New Roman" panose="02020603050405020304" pitchFamily="18" charset="0"/>
             </a:endParaRPr>
@@ -8850,20 +8603,20 @@
                 <a:solidFill>
                   <a:srgbClr val="6FA3CC"/>
                 </a:solidFill>
-                <a:latin typeface="DM Sans" pitchFamily="2" charset="0"/>
+                <a:latin typeface="gobCL" pitchFamily="50" charset="0"/>
                 <a:cs typeface="Times New Roman" panose="02020603050405020304" pitchFamily="18" charset="0"/>
               </a:rPr>
-              <a:t>Periodo de estudio: </a:t>
+              <a:t>Mes de estudio: </a:t>
             </a:r>
             <a:r>
               <a:rPr lang="es-CL" sz="1600" b="1" kern="100" dirty="0">
                 <a:solidFill>
                   <a:srgbClr val="6FA3CC"/>
                 </a:solidFill>
-                <a:latin typeface="DM Mono" panose="020B0509040201040103" pitchFamily="49" charset="0"/>
+                <a:latin typeface="Museo Sans 300" panose="02000000000000000000" pitchFamily="50" charset="0"/>
                 <a:cs typeface="Times New Roman" panose="02020603050405020304" pitchFamily="18" charset="0"/>
               </a:rPr>
-              <a:t>2025-02 → 2026-01</a:t>
+              <a:t>2026-01</a:t>
             </a:r>
           </a:p>
         </p:txBody>
@@ -8976,7 +8729,7 @@
                 <a:solidFill>
                   <a:srgbClr val="002060"/>
                 </a:solidFill>
-                <a:latin typeface="DM Sans" pitchFamily="2" charset="0"/>
+                <a:latin typeface="Museo Sans 500" panose="02000000000000000000" pitchFamily="50" charset="0"/>
                 <a:cs typeface="Times New Roman" panose="02020603050405020304" pitchFamily="18" charset="0"/>
               </a:rPr>
               <a:t>Generación diaria típica por tecnología</a:t>
@@ -8985,7 +8738,7 @@
               <a:solidFill>
                 <a:srgbClr val="002060"/>
               </a:solidFill>
-              <a:latin typeface="DM Sans" pitchFamily="2" charset="0"/>
+              <a:latin typeface="Museo Sans 500" panose="02000000000000000000" pitchFamily="50" charset="0"/>
               <a:cs typeface="Times New Roman" panose="02020603050405020304" pitchFamily="18" charset="0"/>
             </a:endParaRPr>
           </a:p>
@@ -9027,17 +8780,17 @@
                 <a:solidFill>
                   <a:srgbClr val="8A8775"/>
                 </a:solidFill>
-                <a:latin typeface="DM Sans" pitchFamily="2" charset="0"/>
+                <a:latin typeface="Museo Sans 500" panose="02000000000000000000" pitchFamily="50" charset="0"/>
                 <a:cs typeface="Times New Roman" panose="02020603050405020304" pitchFamily="18" charset="0"/>
               </a:rPr>
-              <a:t>Fecha de referencia: 2022-02-24 </a:t>
+              <a:t>Fecha de referencia: 2022-01-17 </a:t>
             </a:r>
             <a:r>
               <a:rPr lang="es-CL" sz="1000" b="1" kern="100" dirty="0">
                 <a:solidFill>
                   <a:srgbClr val="8A8775"/>
                 </a:solidFill>
-                <a:latin typeface="DM Mono" panose="020B0509040201040103" pitchFamily="49" charset="0"/>
+                <a:latin typeface="Museo Sans 500" panose="02000000000000000000" pitchFamily="50" charset="0"/>
                 <a:cs typeface="Times New Roman" panose="02020603050405020304" pitchFamily="18" charset="0"/>
               </a:rPr>
               <a:t/>
@@ -9081,28 +8834,21 @@
                 <a:solidFill>
                   <a:srgbClr val="8A8775"/>
                 </a:solidFill>
-                <a:latin typeface="DM Sans" pitchFamily="2" charset="0"/>
+                <a:latin typeface="Museo Sans 500" panose="02000000000000000000" pitchFamily="50" charset="0"/>
                 <a:cs typeface="Times New Roman" panose="02020603050405020304" pitchFamily="18" charset="0"/>
               </a:rPr>
-              <a:t>Fecha de referencia: 2025-08-11 </a:t>
+              <a:t>Fecha de referencia: 2026-01-12 </a:t>
             </a:r>
             <a:r>
               <a:rPr lang="es-CL" sz="1000" b="1" kern="100" dirty="0">
                 <a:solidFill>
                   <a:srgbClr val="8A8775"/>
                 </a:solidFill>
-                <a:latin typeface="DM Mono" panose="020B0509040201040103" pitchFamily="49" charset="0"/>
+                <a:latin typeface="Museo Sans 500" panose="02000000000000000000" pitchFamily="50" charset="0"/>
                 <a:cs typeface="Times New Roman" panose="02020603050405020304" pitchFamily="18" charset="0"/>
               </a:rPr>
               <a:t/>
             </a:r>
-            <a:endParaRPr lang="es-CL" sz="1000" b="1" kern="100" dirty="0">
-              <a:solidFill>
-                <a:srgbClr val="8A8775"/>
-              </a:solidFill>
-              <a:latin typeface="DM Sans" pitchFamily="2" charset="0"/>
-              <a:cs typeface="Times New Roman" panose="02020603050405020304" pitchFamily="18" charset="0"/>
-            </a:endParaRPr>
           </a:p>
         </p:txBody>
       </p:sp>
@@ -9142,7 +8888,7 @@
                 <a:solidFill>
                   <a:srgbClr val="002060"/>
                 </a:solidFill>
-                <a:latin typeface="DM Sans" pitchFamily="2" charset="0"/>
+                <a:latin typeface="Museo Sans 500" panose="02000000000000000000" pitchFamily="50" charset="0"/>
                 <a:cs typeface="Times New Roman" panose="02020603050405020304" pitchFamily="18" charset="0"/>
               </a:rPr>
               <a:t>MWh</a:t>
@@ -9151,7 +8897,7 @@
               <a:solidFill>
                 <a:srgbClr val="002060"/>
               </a:solidFill>
-              <a:latin typeface="DM Sans" pitchFamily="2" charset="0"/>
+              <a:latin typeface="Museo Sans 500" panose="02000000000000000000" pitchFamily="50" charset="0"/>
               <a:cs typeface="Times New Roman" panose="02020603050405020304" pitchFamily="18" charset="0"/>
             </a:endParaRPr>
           </a:p>
@@ -9193,7 +8939,7 @@
                 <a:solidFill>
                   <a:srgbClr val="002060"/>
                 </a:solidFill>
-                <a:latin typeface="DM Sans" pitchFamily="2" charset="0"/>
+                <a:latin typeface="Museo Sans 500" panose="02000000000000000000" pitchFamily="50" charset="0"/>
                 <a:cs typeface="Times New Roman" panose="02020603050405020304" pitchFamily="18" charset="0"/>
               </a:rPr>
               <a:t>Hora del día</a:t>
@@ -9202,7 +8948,7 @@
               <a:solidFill>
                 <a:srgbClr val="002060"/>
               </a:solidFill>
-              <a:latin typeface="DM Sans" pitchFamily="2" charset="0"/>
+              <a:latin typeface="Museo Sans 500" panose="02000000000000000000" pitchFamily="50" charset="0"/>
               <a:cs typeface="Times New Roman" panose="02020603050405020304" pitchFamily="18" charset="0"/>
             </a:endParaRPr>
           </a:p>
@@ -9244,7 +8990,7 @@
                 <a:solidFill>
                   <a:srgbClr val="002060"/>
                 </a:solidFill>
-                <a:latin typeface="DM Sans" pitchFamily="2" charset="0"/>
+                <a:latin typeface="Museo Sans 500" panose="02000000000000000000" pitchFamily="50" charset="0"/>
                 <a:cs typeface="Times New Roman" panose="02020603050405020304" pitchFamily="18" charset="0"/>
               </a:rPr>
               <a:t>Hora del día</a:t>
@@ -9253,7 +8999,7 @@
               <a:solidFill>
                 <a:srgbClr val="002060"/>
               </a:solidFill>
-              <a:latin typeface="DM Sans" pitchFamily="2" charset="0"/>
+              <a:latin typeface="Museo Sans 500" panose="02000000000000000000" pitchFamily="50" charset="0"/>
               <a:cs typeface="Times New Roman" panose="02020603050405020304" pitchFamily="18" charset="0"/>
             </a:endParaRPr>
           </a:p>

</xml_diff>